<commit_message>
added more files to review 2
</commit_message>
<xml_diff>
--- a/review 2/ppt main/review 2 c6 dctm.pptx
+++ b/review 2/ppt main/review 2 c6 dctm.pptx
@@ -5,10 +5,10 @@
     <p:sldMasterId id="2147483648" r:id="rId1"/>
   </p:sldMasterIdLst>
   <p:notesMasterIdLst>
-    <p:notesMasterId r:id="rId13"/>
+    <p:notesMasterId r:id="rId12"/>
   </p:notesMasterIdLst>
   <p:handoutMasterIdLst>
-    <p:handoutMasterId r:id="rId14"/>
+    <p:handoutMasterId r:id="rId13"/>
   </p:handoutMasterIdLst>
   <p:sldIdLst>
     <p:sldId id="256" r:id="rId2"/>
@@ -18,10 +18,9 @@
     <p:sldId id="264" r:id="rId6"/>
     <p:sldId id="269" r:id="rId7"/>
     <p:sldId id="270" r:id="rId8"/>
-    <p:sldId id="266" r:id="rId9"/>
-    <p:sldId id="268" r:id="rId10"/>
-    <p:sldId id="267" r:id="rId11"/>
-    <p:sldId id="262" r:id="rId12"/>
+    <p:sldId id="268" r:id="rId9"/>
+    <p:sldId id="267" r:id="rId10"/>
+    <p:sldId id="262" r:id="rId11"/>
   </p:sldIdLst>
   <p:sldSz cx="12192000" cy="6858000"/>
   <p:notesSz cx="9947275" cy="6858000"/>
@@ -724,6 +723,829 @@
           <a:bodyPr/>
           <a:lstStyle/>
           <a:p>
+            <a:r>
+              <a:rPr lang="en-IN" sz="1200" b="0" i="0" kern="1200" dirty="0">
+                <a:solidFill>
+                  <a:schemeClr val="tx1"/>
+                </a:solidFill>
+                <a:effectLst/>
+                <a:latin typeface="+mn-lt"/>
+                <a:ea typeface="+mn-ea"/>
+                <a:cs typeface="+mn-cs"/>
+              </a:rPr>
+              <a:t>Good morning, we are Team 06, CSE-C</a:t>
+            </a:r>
+          </a:p>
+          <a:p>
+            <a:r>
+              <a:rPr lang="en-IN" sz="1200" b="0" i="0" kern="1200" dirty="0">
+                <a:solidFill>
+                  <a:schemeClr val="tx1"/>
+                </a:solidFill>
+                <a:effectLst/>
+                <a:latin typeface="+mn-lt"/>
+                <a:ea typeface="+mn-ea"/>
+                <a:cs typeface="+mn-cs"/>
+              </a:rPr>
+              <a:t>Project: DCTM — Diffusion-Based Cyber Threat Modelling</a:t>
+            </a:r>
+          </a:p>
+          <a:p>
+            <a:r>
+              <a:rPr lang="en-IN" sz="1200" b="0" i="0" kern="1200" dirty="0">
+                <a:solidFill>
+                  <a:schemeClr val="tx1"/>
+                </a:solidFill>
+                <a:effectLst/>
+                <a:latin typeface="+mn-lt"/>
+                <a:ea typeface="+mn-ea"/>
+                <a:cs typeface="+mn-cs"/>
+              </a:rPr>
+              <a:t>I'm Neha, teammate is Thrinadh</a:t>
+            </a:r>
+          </a:p>
+          <a:p>
+            <a:r>
+              <a:rPr lang="en-IN" sz="1200" b="0" i="0" kern="1200" dirty="0">
+                <a:solidFill>
+                  <a:schemeClr val="tx1"/>
+                </a:solidFill>
+                <a:effectLst/>
+                <a:latin typeface="+mn-lt"/>
+                <a:ea typeface="+mn-ea"/>
+                <a:cs typeface="+mn-cs"/>
+              </a:rPr>
+              <a:t>Guide: Ms. Duddeda Aishwarya</a:t>
+            </a:r>
+          </a:p>
+          <a:p>
+            <a:endParaRPr lang="en-IN" dirty="0"/>
+          </a:p>
+        </p:txBody>
+      </p:sp>
+    </p:spTree>
+    <p:extLst>
+      <p:ext uri="{BB962C8B-B14F-4D97-AF65-F5344CB8AC3E}">
+        <p14:creationId xmlns:p14="http://schemas.microsoft.com/office/powerpoint/2010/main" val="2099346585"/>
+      </p:ext>
+    </p:extLst>
+  </p:cSld>
+  <p:clrMapOvr>
+    <a:masterClrMapping/>
+  </p:clrMapOvr>
+</p:notes>
+</file>
+
+<file path=ppt/notesSlides/notesSlide2.xml><?xml version="1.0" encoding="utf-8"?>
+<p:notes xmlns:a="http://schemas.openxmlformats.org/drawingml/2006/main" xmlns:r="http://schemas.openxmlformats.org/officeDocument/2006/relationships" xmlns:p="http://schemas.openxmlformats.org/presentationml/2006/main">
+  <p:cSld>
+    <p:spTree>
+      <p:nvGrpSpPr>
+        <p:cNvPr id="1" name=""/>
+        <p:cNvGrpSpPr/>
+        <p:nvPr/>
+      </p:nvGrpSpPr>
+      <p:grpSpPr>
+        <a:xfrm>
+          <a:off x="0" y="0"/>
+          <a:ext cx="0" cy="0"/>
+          <a:chOff x="0" y="0"/>
+          <a:chExt cx="0" cy="0"/>
+        </a:xfrm>
+      </p:grpSpPr>
+      <p:sp>
+        <p:nvSpPr>
+          <p:cNvPr id="2" name="Slide Image Placeholder 1"/>
+          <p:cNvSpPr>
+            <a:spLocks noGrp="1" noRot="1" noChangeAspect="1"/>
+          </p:cNvSpPr>
+          <p:nvPr>
+            <p:ph type="sldImg"/>
+          </p:nvPr>
+        </p:nvSpPr>
+        <p:spPr/>
+      </p:sp>
+      <p:sp>
+        <p:nvSpPr>
+          <p:cNvPr id="3" name="Notes Placeholder 2"/>
+          <p:cNvSpPr>
+            <a:spLocks noGrp="1"/>
+          </p:cNvSpPr>
+          <p:nvPr>
+            <p:ph type="body" idx="1"/>
+          </p:nvPr>
+        </p:nvSpPr>
+        <p:spPr/>
+        <p:txBody>
+          <a:bodyPr/>
+          <a:lstStyle/>
+          <a:p>
+            <a:r>
+              <a:rPr lang="en-US" sz="1200" b="0" i="0" kern="1200" dirty="0">
+                <a:solidFill>
+                  <a:schemeClr val="tx1"/>
+                </a:solidFill>
+                <a:effectLst/>
+                <a:latin typeface="+mn-lt"/>
+                <a:ea typeface="+mn-ea"/>
+                <a:cs typeface="+mn-cs"/>
+              </a:rPr>
+              <a:t>IDS = system that detects network attacks</a:t>
+            </a:r>
+          </a:p>
+          <a:p>
+            <a:r>
+              <a:rPr lang="en-US" sz="1200" b="0" i="0" kern="1200" dirty="0">
+                <a:solidFill>
+                  <a:schemeClr val="tx1"/>
+                </a:solidFill>
+                <a:effectLst/>
+                <a:latin typeface="+mn-lt"/>
+                <a:ea typeface="+mn-ea"/>
+                <a:cs typeface="+mn-cs"/>
+              </a:rPr>
+              <a:t>DEMGAN (existing paper) = 97.42% evasion rate but 3 problems</a:t>
+            </a:r>
+          </a:p>
+          <a:p>
+            <a:r>
+              <a:rPr lang="en-US" sz="1200" b="0" i="0" kern="1200" dirty="0">
+                <a:solidFill>
+                  <a:schemeClr val="tx1"/>
+                </a:solidFill>
+                <a:effectLst/>
+                <a:latin typeface="+mn-lt"/>
+                <a:ea typeface="+mn-ea"/>
+                <a:cs typeface="+mn-cs"/>
+              </a:rPr>
+              <a:t>3 problems: only 10 features, GAN unstable, ignores class imbalance</a:t>
+            </a:r>
+          </a:p>
+          <a:p>
+            <a:r>
+              <a:rPr lang="en-US" sz="1200" b="0" i="0" kern="1200" dirty="0">
+                <a:solidFill>
+                  <a:schemeClr val="tx1"/>
+                </a:solidFill>
+                <a:effectLst/>
+                <a:latin typeface="+mn-lt"/>
+                <a:ea typeface="+mn-ea"/>
+                <a:cs typeface="+mn-cs"/>
+              </a:rPr>
+              <a:t>We built DCTM → fixes all 3</a:t>
+            </a:r>
+          </a:p>
+          <a:p>
+            <a:r>
+              <a:rPr lang="en-US" sz="1200" b="0" i="0" kern="1200" dirty="0">
+                <a:solidFill>
+                  <a:schemeClr val="tx1"/>
+                </a:solidFill>
+                <a:effectLst/>
+                <a:latin typeface="+mn-lt"/>
+                <a:ea typeface="+mn-ea"/>
+                <a:cs typeface="+mn-cs"/>
+              </a:rPr>
+              <a:t>DCTM uses: Diffusion model + SMOTE + 20 features</a:t>
+            </a:r>
+          </a:p>
+          <a:p>
+            <a:r>
+              <a:rPr lang="en-US" sz="1200" b="0" i="0" kern="1200" dirty="0">
+                <a:solidFill>
+                  <a:schemeClr val="tx1"/>
+                </a:solidFill>
+                <a:effectLst/>
+                <a:latin typeface="+mn-lt"/>
+                <a:ea typeface="+mn-ea"/>
+                <a:cs typeface="+mn-cs"/>
+              </a:rPr>
+              <a:t>Tested on 2 datasets, measured with F1 + Precision + Recall too</a:t>
+            </a:r>
+          </a:p>
+          <a:p>
+            <a:endParaRPr lang="en-IN" dirty="0"/>
+          </a:p>
+        </p:txBody>
+      </p:sp>
+    </p:spTree>
+    <p:extLst>
+      <p:ext uri="{BB962C8B-B14F-4D97-AF65-F5344CB8AC3E}">
+        <p14:creationId xmlns:p14="http://schemas.microsoft.com/office/powerpoint/2010/main" val="315468486"/>
+      </p:ext>
+    </p:extLst>
+  </p:cSld>
+  <p:clrMapOvr>
+    <a:masterClrMapping/>
+  </p:clrMapOvr>
+</p:notes>
+</file>
+
+<file path=ppt/notesSlides/notesSlide3.xml><?xml version="1.0" encoding="utf-8"?>
+<p:notes xmlns:a="http://schemas.openxmlformats.org/drawingml/2006/main" xmlns:r="http://schemas.openxmlformats.org/officeDocument/2006/relationships" xmlns:p="http://schemas.openxmlformats.org/presentationml/2006/main">
+  <p:cSld>
+    <p:spTree>
+      <p:nvGrpSpPr>
+        <p:cNvPr id="1" name=""/>
+        <p:cNvGrpSpPr/>
+        <p:nvPr/>
+      </p:nvGrpSpPr>
+      <p:grpSpPr>
+        <a:xfrm>
+          <a:off x="0" y="0"/>
+          <a:ext cx="0" cy="0"/>
+          <a:chOff x="0" y="0"/>
+          <a:chExt cx="0" cy="0"/>
+        </a:xfrm>
+      </p:grpSpPr>
+      <p:sp>
+        <p:nvSpPr>
+          <p:cNvPr id="2" name="Slide Image Placeholder 1"/>
+          <p:cNvSpPr>
+            <a:spLocks noGrp="1" noRot="1" noChangeAspect="1"/>
+          </p:cNvSpPr>
+          <p:nvPr>
+            <p:ph type="sldImg"/>
+          </p:nvPr>
+        </p:nvSpPr>
+        <p:spPr/>
+      </p:sp>
+      <p:sp>
+        <p:nvSpPr>
+          <p:cNvPr id="3" name="Notes Placeholder 2"/>
+          <p:cNvSpPr>
+            <a:spLocks noGrp="1"/>
+          </p:cNvSpPr>
+          <p:nvPr>
+            <p:ph type="body" idx="1"/>
+          </p:nvPr>
+        </p:nvSpPr>
+        <p:spPr/>
+        <p:txBody>
+          <a:bodyPr/>
+          <a:lstStyle/>
+          <a:p>
+            <a:r>
+              <a:rPr lang="en-US" sz="1200" b="0" i="0" kern="1200" dirty="0">
+                <a:solidFill>
+                  <a:schemeClr val="tx1"/>
+                </a:solidFill>
+                <a:effectLst/>
+                <a:latin typeface="+mn-lt"/>
+                <a:ea typeface="+mn-ea"/>
+                <a:cs typeface="+mn-cs"/>
+              </a:rPr>
+              <a:t>Networks face attacks: DDoS, </a:t>
+            </a:r>
+            <a:r>
+              <a:rPr lang="en-US" sz="1200" b="0" i="0" kern="1200" dirty="0" err="1">
+                <a:solidFill>
+                  <a:schemeClr val="tx1"/>
+                </a:solidFill>
+                <a:effectLst/>
+                <a:latin typeface="+mn-lt"/>
+                <a:ea typeface="+mn-ea"/>
+                <a:cs typeface="+mn-cs"/>
+              </a:rPr>
+              <a:t>PortScan</a:t>
+            </a:r>
+            <a:r>
+              <a:rPr lang="en-US" sz="1200" b="0" i="0" kern="1200" dirty="0">
+                <a:solidFill>
+                  <a:schemeClr val="tx1"/>
+                </a:solidFill>
+                <a:effectLst/>
+                <a:latin typeface="+mn-lt"/>
+                <a:ea typeface="+mn-ea"/>
+                <a:cs typeface="+mn-cs"/>
+              </a:rPr>
+              <a:t>, SQL Injection etc.</a:t>
+            </a:r>
+          </a:p>
+          <a:p>
+            <a:r>
+              <a:rPr lang="en-US" sz="1200" b="0" i="0" kern="1200" dirty="0">
+                <a:solidFill>
+                  <a:schemeClr val="tx1"/>
+                </a:solidFill>
+                <a:effectLst/>
+                <a:latin typeface="+mn-lt"/>
+                <a:ea typeface="+mn-ea"/>
+                <a:cs typeface="+mn-cs"/>
+              </a:rPr>
+              <a:t>IDS = ML model that labels traffic as Safe or Attack</a:t>
+            </a:r>
+          </a:p>
+          <a:p>
+            <a:r>
+              <a:rPr lang="en-US" sz="1200" b="0" i="0" kern="1200" dirty="0">
+                <a:solidFill>
+                  <a:schemeClr val="tx1"/>
+                </a:solidFill>
+                <a:effectLst/>
+                <a:latin typeface="+mn-lt"/>
+                <a:ea typeface="+mn-ea"/>
+                <a:cs typeface="+mn-cs"/>
+              </a:rPr>
+              <a:t>Problem → attacker can craft fake "safe-looking" traffic → IDS gets fooled</a:t>
+            </a:r>
+          </a:p>
+          <a:p>
+            <a:r>
+              <a:rPr lang="en-US" sz="1200" b="0" i="0" kern="1200" dirty="0">
+                <a:solidFill>
+                  <a:schemeClr val="tx1"/>
+                </a:solidFill>
+                <a:effectLst/>
+                <a:latin typeface="+mn-lt"/>
+                <a:ea typeface="+mn-ea"/>
+                <a:cs typeface="+mn-cs"/>
+              </a:rPr>
+              <a:t>This is called an evasion attack</a:t>
+            </a:r>
+          </a:p>
+          <a:p>
+            <a:r>
+              <a:rPr lang="en-US" sz="1200" b="0" i="0" kern="1200" dirty="0">
+                <a:solidFill>
+                  <a:schemeClr val="tx1"/>
+                </a:solidFill>
+                <a:effectLst/>
+                <a:latin typeface="+mn-lt"/>
+                <a:ea typeface="+mn-ea"/>
+                <a:cs typeface="+mn-cs"/>
+              </a:rPr>
+              <a:t>We need tools to test how easily IDS gets fooled</a:t>
+            </a:r>
+          </a:p>
+          <a:p>
+            <a:r>
+              <a:rPr lang="en-US" sz="1200" b="0" i="0" kern="1200" dirty="0">
+                <a:solidFill>
+                  <a:schemeClr val="tx1"/>
+                </a:solidFill>
+                <a:effectLst/>
+                <a:latin typeface="+mn-lt"/>
+                <a:ea typeface="+mn-ea"/>
+                <a:cs typeface="+mn-cs"/>
+              </a:rPr>
+              <a:t>DEMGAN does this with GAN → we do it better with Diffusion</a:t>
+            </a:r>
+          </a:p>
+          <a:p>
+            <a:r>
+              <a:rPr lang="en-US" sz="1200" b="0" i="0" kern="1200" dirty="0">
+                <a:solidFill>
+                  <a:schemeClr val="tx1"/>
+                </a:solidFill>
+                <a:effectLst/>
+                <a:latin typeface="+mn-lt"/>
+                <a:ea typeface="+mn-ea"/>
+                <a:cs typeface="+mn-cs"/>
+              </a:rPr>
+              <a:t>Our tool works both ways → attack IDS AND strengthen it</a:t>
+            </a:r>
+          </a:p>
+          <a:p>
+            <a:endParaRPr lang="en-IN" dirty="0"/>
+          </a:p>
+        </p:txBody>
+      </p:sp>
+    </p:spTree>
+    <p:extLst>
+      <p:ext uri="{BB962C8B-B14F-4D97-AF65-F5344CB8AC3E}">
+        <p14:creationId xmlns:p14="http://schemas.microsoft.com/office/powerpoint/2010/main" val="3254412759"/>
+      </p:ext>
+    </p:extLst>
+  </p:cSld>
+  <p:clrMapOvr>
+    <a:masterClrMapping/>
+  </p:clrMapOvr>
+</p:notes>
+</file>
+
+<file path=ppt/notesSlides/notesSlide4.xml><?xml version="1.0" encoding="utf-8"?>
+<p:notes xmlns:a="http://schemas.openxmlformats.org/drawingml/2006/main" xmlns:r="http://schemas.openxmlformats.org/officeDocument/2006/relationships" xmlns:p="http://schemas.openxmlformats.org/presentationml/2006/main">
+  <p:cSld>
+    <p:spTree>
+      <p:nvGrpSpPr>
+        <p:cNvPr id="1" name=""/>
+        <p:cNvGrpSpPr/>
+        <p:nvPr/>
+      </p:nvGrpSpPr>
+      <p:grpSpPr>
+        <a:xfrm>
+          <a:off x="0" y="0"/>
+          <a:ext cx="0" cy="0"/>
+          <a:chOff x="0" y="0"/>
+          <a:chExt cx="0" cy="0"/>
+        </a:xfrm>
+      </p:grpSpPr>
+      <p:sp>
+        <p:nvSpPr>
+          <p:cNvPr id="2" name="Slide Image Placeholder 1"/>
+          <p:cNvSpPr>
+            <a:spLocks noGrp="1" noRot="1" noChangeAspect="1"/>
+          </p:cNvSpPr>
+          <p:nvPr>
+            <p:ph type="sldImg"/>
+          </p:nvPr>
+        </p:nvSpPr>
+        <p:spPr/>
+      </p:sp>
+      <p:sp>
+        <p:nvSpPr>
+          <p:cNvPr id="3" name="Notes Placeholder 2"/>
+          <p:cNvSpPr>
+            <a:spLocks noGrp="1"/>
+          </p:cNvSpPr>
+          <p:nvPr>
+            <p:ph type="body" idx="1"/>
+          </p:nvPr>
+        </p:nvSpPr>
+        <p:spPr/>
+        <p:txBody>
+          <a:bodyPr/>
+          <a:lstStyle/>
+          <a:p>
+            <a:r>
+              <a:rPr lang="en-US" sz="1200" b="1" i="0" kern="1200" dirty="0">
+                <a:solidFill>
+                  <a:schemeClr val="tx1"/>
+                </a:solidFill>
+                <a:effectLst/>
+                <a:latin typeface="+mn-lt"/>
+                <a:ea typeface="+mn-ea"/>
+                <a:cs typeface="+mn-cs"/>
+              </a:rPr>
+              <a:t>Gaps (what's wrong with DEMGAN):</a:t>
+            </a:r>
+            <a:endParaRPr lang="en-US" sz="1200" b="0" i="0" kern="1200" dirty="0">
+              <a:solidFill>
+                <a:schemeClr val="tx1"/>
+              </a:solidFill>
+              <a:effectLst/>
+              <a:latin typeface="+mn-lt"/>
+              <a:ea typeface="+mn-ea"/>
+              <a:cs typeface="+mn-cs"/>
+            </a:endParaRPr>
+          </a:p>
+          <a:p>
+            <a:r>
+              <a:rPr lang="en-US" sz="1200" b="0" i="0" kern="1200" dirty="0">
+                <a:solidFill>
+                  <a:schemeClr val="tx1"/>
+                </a:solidFill>
+                <a:effectLst/>
+                <a:latin typeface="+mn-lt"/>
+                <a:ea typeface="+mn-ea"/>
+                <a:cs typeface="+mn-cs"/>
+              </a:rPr>
+              <a:t>Only 10 features used → too limited</a:t>
+            </a:r>
+          </a:p>
+          <a:p>
+            <a:r>
+              <a:rPr lang="en-US" sz="1200" b="0" i="0" kern="1200" dirty="0">
+                <a:solidFill>
+                  <a:schemeClr val="tx1"/>
+                </a:solidFill>
+                <a:effectLst/>
+                <a:latin typeface="+mn-lt"/>
+                <a:ea typeface="+mn-ea"/>
+                <a:cs typeface="+mn-cs"/>
+              </a:rPr>
+              <a:t>GAN is unstable → bad on Decision Tree and Logistic Regression</a:t>
+            </a:r>
+          </a:p>
+          <a:p>
+            <a:r>
+              <a:rPr lang="en-US" sz="1200" b="0" i="0" kern="1200" dirty="0">
+                <a:solidFill>
+                  <a:schemeClr val="tx1"/>
+                </a:solidFill>
+                <a:effectLst/>
+                <a:latin typeface="+mn-lt"/>
+                <a:ea typeface="+mn-ea"/>
+                <a:cs typeface="+mn-cs"/>
+              </a:rPr>
+              <a:t>Rare attacks ignored → Heartbleed has only 11 samples</a:t>
+            </a:r>
+          </a:p>
+          <a:p>
+            <a:r>
+              <a:rPr lang="en-US" sz="1200" b="0" i="0" kern="1200" dirty="0">
+                <a:solidFill>
+                  <a:schemeClr val="tx1"/>
+                </a:solidFill>
+                <a:effectLst/>
+                <a:latin typeface="+mn-lt"/>
+                <a:ea typeface="+mn-ea"/>
+                <a:cs typeface="+mn-cs"/>
+              </a:rPr>
+              <a:t>Only evasion rate measured → no F1, Precision, Recall</a:t>
+            </a:r>
+          </a:p>
+          <a:p>
+            <a:r>
+              <a:rPr lang="en-US" sz="1200" b="1" i="0" kern="1200" dirty="0">
+                <a:solidFill>
+                  <a:schemeClr val="tx1"/>
+                </a:solidFill>
+                <a:effectLst/>
+                <a:latin typeface="+mn-lt"/>
+                <a:ea typeface="+mn-ea"/>
+                <a:cs typeface="+mn-cs"/>
+              </a:rPr>
+              <a:t>Our fix:</a:t>
+            </a:r>
+            <a:endParaRPr lang="en-US" sz="1200" b="0" i="0" kern="1200" dirty="0">
+              <a:solidFill>
+                <a:schemeClr val="tx1"/>
+              </a:solidFill>
+              <a:effectLst/>
+              <a:latin typeface="+mn-lt"/>
+              <a:ea typeface="+mn-ea"/>
+              <a:cs typeface="+mn-cs"/>
+            </a:endParaRPr>
+          </a:p>
+          <a:p>
+            <a:r>
+              <a:rPr lang="en-US" sz="1200" b="0" i="0" kern="1200" dirty="0">
+                <a:solidFill>
+                  <a:schemeClr val="tx1"/>
+                </a:solidFill>
+                <a:effectLst/>
+                <a:latin typeface="+mn-lt"/>
+                <a:ea typeface="+mn-ea"/>
+                <a:cs typeface="+mn-cs"/>
+              </a:rPr>
+              <a:t>Replace GAN → Diffusion model (stable)</a:t>
+            </a:r>
+          </a:p>
+          <a:p>
+            <a:r>
+              <a:rPr lang="en-US" sz="1200" b="0" i="0" kern="1200" dirty="0">
+                <a:solidFill>
+                  <a:schemeClr val="tx1"/>
+                </a:solidFill>
+                <a:effectLst/>
+                <a:latin typeface="+mn-lt"/>
+                <a:ea typeface="+mn-ea"/>
+                <a:cs typeface="+mn-cs"/>
+              </a:rPr>
+              <a:t>10 → 20 features using MI + SHAP</a:t>
+            </a:r>
+          </a:p>
+          <a:p>
+            <a:r>
+              <a:rPr lang="en-US" sz="1200" b="0" i="0" kern="1200" dirty="0">
+                <a:solidFill>
+                  <a:schemeClr val="tx1"/>
+                </a:solidFill>
+                <a:effectLst/>
+                <a:latin typeface="+mn-lt"/>
+                <a:ea typeface="+mn-ea"/>
+                <a:cs typeface="+mn-cs"/>
+              </a:rPr>
+              <a:t>SMOTE → fixes class imbalance</a:t>
+            </a:r>
+          </a:p>
+          <a:p>
+            <a:r>
+              <a:rPr lang="en-US" sz="1200" b="0" i="0" kern="1200" dirty="0">
+                <a:solidFill>
+                  <a:schemeClr val="tx1"/>
+                </a:solidFill>
+                <a:effectLst/>
+                <a:latin typeface="+mn-lt"/>
+                <a:ea typeface="+mn-ea"/>
+                <a:cs typeface="+mn-cs"/>
+              </a:rPr>
+              <a:t>Add F1, Precision, Recall to evaluation</a:t>
+            </a:r>
+          </a:p>
+          <a:p>
+            <a:endParaRPr lang="en-IN" dirty="0"/>
+          </a:p>
+        </p:txBody>
+      </p:sp>
+    </p:spTree>
+    <p:extLst>
+      <p:ext uri="{BB962C8B-B14F-4D97-AF65-F5344CB8AC3E}">
+        <p14:creationId xmlns:p14="http://schemas.microsoft.com/office/powerpoint/2010/main" val="2141373697"/>
+      </p:ext>
+    </p:extLst>
+  </p:cSld>
+  <p:clrMapOvr>
+    <a:masterClrMapping/>
+  </p:clrMapOvr>
+</p:notes>
+</file>
+
+<file path=ppt/notesSlides/notesSlide5.xml><?xml version="1.0" encoding="utf-8"?>
+<p:notes xmlns:a="http://schemas.openxmlformats.org/drawingml/2006/main" xmlns:r="http://schemas.openxmlformats.org/officeDocument/2006/relationships" xmlns:p="http://schemas.openxmlformats.org/presentationml/2006/main">
+  <p:cSld>
+    <p:spTree>
+      <p:nvGrpSpPr>
+        <p:cNvPr id="1" name=""/>
+        <p:cNvGrpSpPr/>
+        <p:nvPr/>
+      </p:nvGrpSpPr>
+      <p:grpSpPr>
+        <a:xfrm>
+          <a:off x="0" y="0"/>
+          <a:ext cx="0" cy="0"/>
+          <a:chOff x="0" y="0"/>
+          <a:chExt cx="0" cy="0"/>
+        </a:xfrm>
+      </p:grpSpPr>
+      <p:sp>
+        <p:nvSpPr>
+          <p:cNvPr id="2" name="Slide Image Placeholder 1"/>
+          <p:cNvSpPr>
+            <a:spLocks noGrp="1" noRot="1" noChangeAspect="1"/>
+          </p:cNvSpPr>
+          <p:nvPr>
+            <p:ph type="sldImg"/>
+          </p:nvPr>
+        </p:nvSpPr>
+        <p:spPr/>
+      </p:sp>
+      <p:sp>
+        <p:nvSpPr>
+          <p:cNvPr id="3" name="Notes Placeholder 2"/>
+          <p:cNvSpPr>
+            <a:spLocks noGrp="1"/>
+          </p:cNvSpPr>
+          <p:nvPr>
+            <p:ph type="body" idx="1"/>
+          </p:nvPr>
+        </p:nvSpPr>
+        <p:spPr/>
+        <p:txBody>
+          <a:bodyPr/>
+          <a:lstStyle/>
+          <a:p>
+            <a:r>
+              <a:rPr lang="en-IN" sz="1200" b="0" i="0" kern="1200" dirty="0">
+                <a:solidFill>
+                  <a:schemeClr val="tx1"/>
+                </a:solidFill>
+                <a:effectLst/>
+                <a:latin typeface="+mn-lt"/>
+                <a:ea typeface="+mn-ea"/>
+                <a:cs typeface="+mn-cs"/>
+              </a:rPr>
+              <a:t>Start: raw CSV files (CICIDS2017 dataset)</a:t>
+            </a:r>
+          </a:p>
+          <a:p>
+            <a:r>
+              <a:rPr lang="en-IN" sz="1200" b="0" i="0" kern="1200" dirty="0">
+                <a:solidFill>
+                  <a:schemeClr val="tx1"/>
+                </a:solidFill>
+                <a:effectLst/>
+                <a:latin typeface="+mn-lt"/>
+                <a:ea typeface="+mn-ea"/>
+                <a:cs typeface="+mn-cs"/>
+              </a:rPr>
+              <a:t>Step 1: clean data → remove bad rows → normalize to 0-1</a:t>
+            </a:r>
+          </a:p>
+          <a:p>
+            <a:r>
+              <a:rPr lang="en-IN" sz="1200" b="0" i="0" kern="1200" dirty="0">
+                <a:solidFill>
+                  <a:schemeClr val="tx1"/>
+                </a:solidFill>
+                <a:effectLst/>
+                <a:latin typeface="+mn-lt"/>
+                <a:ea typeface="+mn-ea"/>
+                <a:cs typeface="+mn-cs"/>
+              </a:rPr>
+              <a:t>Step 2: pick top 20 features using MI + SHAP combined</a:t>
+            </a:r>
+          </a:p>
+          <a:p>
+            <a:r>
+              <a:rPr lang="en-IN" sz="1200" b="0" i="0" kern="1200" dirty="0">
+                <a:solidFill>
+                  <a:schemeClr val="tx1"/>
+                </a:solidFill>
+                <a:effectLst/>
+                <a:latin typeface="+mn-lt"/>
+                <a:ea typeface="+mn-ea"/>
+                <a:cs typeface="+mn-cs"/>
+              </a:rPr>
+              <a:t>Step 3: SMOTE → balance rare attack classes → train 10 IDS models</a:t>
+            </a:r>
+          </a:p>
+          <a:p>
+            <a:r>
+              <a:rPr lang="en-IN" sz="1200" b="0" i="0" kern="1200" dirty="0">
+                <a:solidFill>
+                  <a:schemeClr val="tx1"/>
+                </a:solidFill>
+                <a:effectLst/>
+                <a:latin typeface="+mn-lt"/>
+                <a:ea typeface="+mn-ea"/>
+                <a:cs typeface="+mn-cs"/>
+              </a:rPr>
+              <a:t>Step 4: train Diffusion model per attack class</a:t>
+            </a:r>
+          </a:p>
+          <a:p>
+            <a:r>
+              <a:rPr lang="en-IN" sz="1200" b="0" i="0" kern="1200" dirty="0">
+                <a:solidFill>
+                  <a:schemeClr val="tx1"/>
+                </a:solidFill>
+                <a:effectLst/>
+                <a:latin typeface="+mn-lt"/>
+                <a:ea typeface="+mn-ea"/>
+                <a:cs typeface="+mn-cs"/>
+              </a:rPr>
+              <a:t>Step 5: generate adversarial samples → test on IDS → measure evasion rate</a:t>
+            </a:r>
+          </a:p>
+          <a:p>
+            <a:r>
+              <a:rPr lang="en-IN" sz="1200" b="0" i="0" kern="1200" dirty="0">
+                <a:solidFill>
+                  <a:schemeClr val="tx1"/>
+                </a:solidFill>
+                <a:effectLst/>
+                <a:latin typeface="+mn-lt"/>
+                <a:ea typeface="+mn-ea"/>
+                <a:cs typeface="+mn-cs"/>
+              </a:rPr>
+              <a:t>End: retrain IDS with adversarial data → IDS becomes stronger</a:t>
+            </a:r>
+          </a:p>
+          <a:p>
+            <a:endParaRPr lang="en-IN" dirty="0"/>
+          </a:p>
+        </p:txBody>
+      </p:sp>
+    </p:spTree>
+    <p:extLst>
+      <p:ext uri="{BB962C8B-B14F-4D97-AF65-F5344CB8AC3E}">
+        <p14:creationId xmlns:p14="http://schemas.microsoft.com/office/powerpoint/2010/main" val="3520691686"/>
+      </p:ext>
+    </p:extLst>
+  </p:cSld>
+  <p:clrMapOvr>
+    <a:masterClrMapping/>
+  </p:clrMapOvr>
+</p:notes>
+</file>
+
+<file path=ppt/notesSlides/notesSlide6.xml><?xml version="1.0" encoding="utf-8"?>
+<p:notes xmlns:a="http://schemas.openxmlformats.org/drawingml/2006/main" xmlns:r="http://schemas.openxmlformats.org/officeDocument/2006/relationships" xmlns:p="http://schemas.openxmlformats.org/presentationml/2006/main">
+  <p:cSld>
+    <p:spTree>
+      <p:nvGrpSpPr>
+        <p:cNvPr id="1" name=""/>
+        <p:cNvGrpSpPr/>
+        <p:nvPr/>
+      </p:nvGrpSpPr>
+      <p:grpSpPr>
+        <a:xfrm>
+          <a:off x="0" y="0"/>
+          <a:ext cx="0" cy="0"/>
+          <a:chOff x="0" y="0"/>
+          <a:chExt cx="0" cy="0"/>
+        </a:xfrm>
+      </p:grpSpPr>
+      <p:sp>
+        <p:nvSpPr>
+          <p:cNvPr id="2" name="Slide Image Placeholder 1"/>
+          <p:cNvSpPr>
+            <a:spLocks noGrp="1" noRot="1" noChangeAspect="1"/>
+          </p:cNvSpPr>
+          <p:nvPr>
+            <p:ph type="sldImg"/>
+          </p:nvPr>
+        </p:nvSpPr>
+        <p:spPr/>
+      </p:sp>
+      <p:sp>
+        <p:nvSpPr>
+          <p:cNvPr id="3" name="Notes Placeholder 2"/>
+          <p:cNvSpPr>
+            <a:spLocks noGrp="1"/>
+          </p:cNvSpPr>
+          <p:nvPr>
+            <p:ph type="body" idx="1"/>
+          </p:nvPr>
+        </p:nvSpPr>
+        <p:spPr/>
+        <p:txBody>
+          <a:bodyPr/>
+          <a:lstStyle/>
+          <a:p>
             <a:endParaRPr lang="en-IN" dirty="0"/>
           </a:p>
         </p:txBody>
@@ -732,6 +1554,324 @@
     <p:extLst>
       <p:ext uri="{BB962C8B-B14F-4D97-AF65-F5344CB8AC3E}">
         <p14:creationId xmlns:p14="http://schemas.microsoft.com/office/powerpoint/2010/main" val="2610421372"/>
+      </p:ext>
+    </p:extLst>
+  </p:cSld>
+  <p:clrMapOvr>
+    <a:masterClrMapping/>
+  </p:clrMapOvr>
+</p:notes>
+</file>
+
+<file path=ppt/notesSlides/notesSlide7.xml><?xml version="1.0" encoding="utf-8"?>
+<p:notes xmlns:a="http://schemas.openxmlformats.org/drawingml/2006/main" xmlns:r="http://schemas.openxmlformats.org/officeDocument/2006/relationships" xmlns:p="http://schemas.openxmlformats.org/presentationml/2006/main">
+  <p:cSld>
+    <p:spTree>
+      <p:nvGrpSpPr>
+        <p:cNvPr id="1" name=""/>
+        <p:cNvGrpSpPr/>
+        <p:nvPr/>
+      </p:nvGrpSpPr>
+      <p:grpSpPr>
+        <a:xfrm>
+          <a:off x="0" y="0"/>
+          <a:ext cx="0" cy="0"/>
+          <a:chOff x="0" y="0"/>
+          <a:chExt cx="0" cy="0"/>
+        </a:xfrm>
+      </p:grpSpPr>
+      <p:sp>
+        <p:nvSpPr>
+          <p:cNvPr id="2" name="Slide Image Placeholder 1"/>
+          <p:cNvSpPr>
+            <a:spLocks noGrp="1" noRot="1" noChangeAspect="1"/>
+          </p:cNvSpPr>
+          <p:nvPr>
+            <p:ph type="sldImg"/>
+          </p:nvPr>
+        </p:nvSpPr>
+        <p:spPr/>
+      </p:sp>
+      <p:sp>
+        <p:nvSpPr>
+          <p:cNvPr id="3" name="Notes Placeholder 2"/>
+          <p:cNvSpPr>
+            <a:spLocks noGrp="1"/>
+          </p:cNvSpPr>
+          <p:nvPr>
+            <p:ph type="body" idx="1"/>
+          </p:nvPr>
+        </p:nvSpPr>
+        <p:spPr/>
+        <p:txBody>
+          <a:bodyPr/>
+          <a:lstStyle/>
+          <a:p>
+            <a:r>
+              <a:rPr lang="en-US" sz="1200" b="1" i="0" kern="1200" dirty="0">
+                <a:solidFill>
+                  <a:schemeClr val="tx1"/>
+                </a:solidFill>
+                <a:effectLst/>
+                <a:latin typeface="+mn-lt"/>
+                <a:ea typeface="+mn-ea"/>
+                <a:cs typeface="+mn-cs"/>
+              </a:rPr>
+              <a:t>CICIDS2017:</a:t>
+            </a:r>
+            <a:endParaRPr lang="en-US" sz="1200" b="0" i="0" kern="1200" dirty="0">
+              <a:solidFill>
+                <a:schemeClr val="tx1"/>
+              </a:solidFill>
+              <a:effectLst/>
+              <a:latin typeface="+mn-lt"/>
+              <a:ea typeface="+mn-ea"/>
+              <a:cs typeface="+mn-cs"/>
+            </a:endParaRPr>
+          </a:p>
+          <a:p>
+            <a:r>
+              <a:rPr lang="en-US" sz="1200" b="0" i="0" kern="1200" dirty="0">
+                <a:solidFill>
+                  <a:schemeClr val="tx1"/>
+                </a:solidFill>
+                <a:effectLst/>
+                <a:latin typeface="+mn-lt"/>
+                <a:ea typeface="+mn-ea"/>
+                <a:cs typeface="+mn-cs"/>
+              </a:rPr>
+              <a:t>2.83 million samples, 79 features, 14 attack types</a:t>
+            </a:r>
+          </a:p>
+          <a:p>
+            <a:r>
+              <a:rPr lang="en-US" sz="1200" b="0" i="0" kern="1200" dirty="0">
+                <a:solidFill>
+                  <a:schemeClr val="tx1"/>
+                </a:solidFill>
+                <a:effectLst/>
+                <a:latin typeface="+mn-lt"/>
+                <a:ea typeface="+mn-ea"/>
+                <a:cs typeface="+mn-cs"/>
+              </a:rPr>
+              <a:t>Main training + evaluation dataset</a:t>
+            </a:r>
+          </a:p>
+          <a:p>
+            <a:r>
+              <a:rPr lang="en-US" sz="1200" b="0" i="0" kern="1200" dirty="0">
+                <a:solidFill>
+                  <a:schemeClr val="tx1"/>
+                </a:solidFill>
+                <a:effectLst/>
+                <a:latin typeface="+mn-lt"/>
+                <a:ea typeface="+mn-ea"/>
+                <a:cs typeface="+mn-cs"/>
+              </a:rPr>
+              <a:t>Same dataset used in DEMGAN</a:t>
+            </a:r>
+          </a:p>
+          <a:p>
+            <a:r>
+              <a:rPr lang="en-US" sz="1200" b="1" i="0" kern="1200" dirty="0">
+                <a:solidFill>
+                  <a:schemeClr val="tx1"/>
+                </a:solidFill>
+                <a:effectLst/>
+                <a:latin typeface="+mn-lt"/>
+                <a:ea typeface="+mn-ea"/>
+                <a:cs typeface="+mn-cs"/>
+              </a:rPr>
+              <a:t>CICIDS2018:</a:t>
+            </a:r>
+            <a:endParaRPr lang="en-US" sz="1200" b="0" i="0" kern="1200" dirty="0">
+              <a:solidFill>
+                <a:schemeClr val="tx1"/>
+              </a:solidFill>
+              <a:effectLst/>
+              <a:latin typeface="+mn-lt"/>
+              <a:ea typeface="+mn-ea"/>
+              <a:cs typeface="+mn-cs"/>
+            </a:endParaRPr>
+          </a:p>
+          <a:p>
+            <a:r>
+              <a:rPr lang="en-US" sz="1200" b="0" i="0" kern="1200" dirty="0">
+                <a:solidFill>
+                  <a:schemeClr val="tx1"/>
+                </a:solidFill>
+                <a:effectLst/>
+                <a:latin typeface="+mn-lt"/>
+                <a:ea typeface="+mn-ea"/>
+                <a:cs typeface="+mn-cs"/>
+              </a:rPr>
+              <a:t>2M+ samples, 4 attack types</a:t>
+            </a:r>
+          </a:p>
+          <a:p>
+            <a:r>
+              <a:rPr lang="en-US" sz="1200" b="0" i="0" kern="1200" dirty="0">
+                <a:solidFill>
+                  <a:schemeClr val="tx1"/>
+                </a:solidFill>
+                <a:effectLst/>
+                <a:latin typeface="+mn-lt"/>
+                <a:ea typeface="+mn-ea"/>
+                <a:cs typeface="+mn-cs"/>
+              </a:rPr>
+              <a:t>Only for </a:t>
+            </a:r>
+            <a:r>
+              <a:rPr lang="en-US" sz="1200" b="0" i="0" kern="1200" dirty="0" err="1">
+                <a:solidFill>
+                  <a:schemeClr val="tx1"/>
+                </a:solidFill>
+                <a:effectLst/>
+                <a:latin typeface="+mn-lt"/>
+                <a:ea typeface="+mn-ea"/>
+                <a:cs typeface="+mn-cs"/>
+              </a:rPr>
+              <a:t>generalisation</a:t>
+            </a:r>
+            <a:r>
+              <a:rPr lang="en-US" sz="1200" b="0" i="0" kern="1200" dirty="0">
+                <a:solidFill>
+                  <a:schemeClr val="tx1"/>
+                </a:solidFill>
+                <a:effectLst/>
+                <a:latin typeface="+mn-lt"/>
+                <a:ea typeface="+mn-ea"/>
+                <a:cs typeface="+mn-cs"/>
+              </a:rPr>
+              <a:t> testing → never used in training</a:t>
+            </a:r>
+          </a:p>
+          <a:p>
+            <a:endParaRPr lang="en-IN" dirty="0"/>
+          </a:p>
+        </p:txBody>
+      </p:sp>
+    </p:spTree>
+    <p:extLst>
+      <p:ext uri="{BB962C8B-B14F-4D97-AF65-F5344CB8AC3E}">
+        <p14:creationId xmlns:p14="http://schemas.microsoft.com/office/powerpoint/2010/main" val="2097489531"/>
+      </p:ext>
+    </p:extLst>
+  </p:cSld>
+  <p:clrMapOvr>
+    <a:masterClrMapping/>
+  </p:clrMapOvr>
+</p:notes>
+</file>
+
+<file path=ppt/notesSlides/notesSlide8.xml><?xml version="1.0" encoding="utf-8"?>
+<p:notes xmlns:a="http://schemas.openxmlformats.org/drawingml/2006/main" xmlns:r="http://schemas.openxmlformats.org/officeDocument/2006/relationships" xmlns:p="http://schemas.openxmlformats.org/presentationml/2006/main">
+  <p:cSld>
+    <p:spTree>
+      <p:nvGrpSpPr>
+        <p:cNvPr id="1" name=""/>
+        <p:cNvGrpSpPr/>
+        <p:nvPr/>
+      </p:nvGrpSpPr>
+      <p:grpSpPr>
+        <a:xfrm>
+          <a:off x="0" y="0"/>
+          <a:ext cx="0" cy="0"/>
+          <a:chOff x="0" y="0"/>
+          <a:chExt cx="0" cy="0"/>
+        </a:xfrm>
+      </p:grpSpPr>
+      <p:sp>
+        <p:nvSpPr>
+          <p:cNvPr id="2" name="Slide Image Placeholder 1"/>
+          <p:cNvSpPr>
+            <a:spLocks noGrp="1" noRot="1" noChangeAspect="1"/>
+          </p:cNvSpPr>
+          <p:nvPr>
+            <p:ph type="sldImg"/>
+          </p:nvPr>
+        </p:nvSpPr>
+        <p:spPr/>
+      </p:sp>
+      <p:sp>
+        <p:nvSpPr>
+          <p:cNvPr id="3" name="Notes Placeholder 2"/>
+          <p:cNvSpPr>
+            <a:spLocks noGrp="1"/>
+          </p:cNvSpPr>
+          <p:nvPr>
+            <p:ph type="body" idx="1"/>
+          </p:nvPr>
+        </p:nvSpPr>
+        <p:spPr/>
+        <p:txBody>
+          <a:bodyPr/>
+          <a:lstStyle/>
+          <a:p>
+            <a:r>
+              <a:rPr lang="en-IN" sz="1200" b="0" i="0" kern="1200" dirty="0">
+                <a:solidFill>
+                  <a:schemeClr val="tx1"/>
+                </a:solidFill>
+                <a:effectLst/>
+                <a:latin typeface="+mn-lt"/>
+                <a:ea typeface="+mn-ea"/>
+                <a:cs typeface="+mn-cs"/>
+              </a:rPr>
+              <a:t>DEMGAN 2025 → base paper we are improving</a:t>
+            </a:r>
+          </a:p>
+          <a:p>
+            <a:r>
+              <a:rPr lang="en-IN" sz="1200" b="0" i="0" kern="1200" dirty="0">
+                <a:solidFill>
+                  <a:schemeClr val="tx1"/>
+                </a:solidFill>
+                <a:effectLst/>
+                <a:latin typeface="+mn-lt"/>
+                <a:ea typeface="+mn-ea"/>
+                <a:cs typeface="+mn-cs"/>
+              </a:rPr>
+              <a:t>Wasserstein GAN 2017 → what DEMGAN was built on</a:t>
+            </a:r>
+          </a:p>
+          <a:p>
+            <a:r>
+              <a:rPr lang="en-IN" sz="1200" b="0" i="0" kern="1200" dirty="0">
+                <a:solidFill>
+                  <a:schemeClr val="tx1"/>
+                </a:solidFill>
+                <a:effectLst/>
+                <a:latin typeface="+mn-lt"/>
+                <a:ea typeface="+mn-ea"/>
+                <a:cs typeface="+mn-cs"/>
+              </a:rPr>
+              <a:t>SMOTE 2002 → for class balancing</a:t>
+            </a:r>
+          </a:p>
+          <a:p>
+            <a:r>
+              <a:rPr lang="en-IN" sz="1200" b="0" i="0" kern="1200" dirty="0">
+                <a:solidFill>
+                  <a:schemeClr val="tx1"/>
+                </a:solidFill>
+                <a:effectLst/>
+                <a:latin typeface="+mn-lt"/>
+                <a:ea typeface="+mn-ea"/>
+                <a:cs typeface="+mn-cs"/>
+              </a:rPr>
+              <a:t>CICIDS dataset paper → dataset we used</a:t>
+            </a:r>
+          </a:p>
+          <a:p>
+            <a:endParaRPr lang="en-IN" dirty="0"/>
+          </a:p>
+        </p:txBody>
+      </p:sp>
+    </p:spTree>
+    <p:extLst>
+      <p:ext uri="{BB962C8B-B14F-4D97-AF65-F5344CB8AC3E}">
+        <p14:creationId xmlns:p14="http://schemas.microsoft.com/office/powerpoint/2010/main" val="4235260555"/>
       </p:ext>
     </p:extLst>
   </p:cSld>
@@ -8335,7 +9475,7 @@
               </a:tabLst>
             </a:pPr>
             <a:r>
-              <a:rPr lang="en-US" sz="3200" b="1" u="none" strike="noStrike">
+              <a:rPr lang="en-US" sz="3200" b="1" u="none" strike="noStrike" dirty="0">
                 <a:solidFill>
                   <a:srgbClr val="000000"/>
                 </a:solidFill>
@@ -8346,10 +9486,10 @@
               <a:t>KESHAV MEMORIAL ENGINEERING COLLEGE</a:t>
             </a:r>
             <a:br>
-              <a:rPr sz="3200"/>
+              <a:rPr sz="3200" dirty="0"/>
             </a:br>
             <a:r>
-              <a:rPr lang="en-US" sz="2000" b="1" u="none" strike="noStrike">
+              <a:rPr lang="en-US" sz="2000" b="1" u="none" strike="noStrike" dirty="0">
                 <a:solidFill>
                   <a:srgbClr val="000000"/>
                 </a:solidFill>
@@ -8360,7 +9500,7 @@
               <a:t>A unit of Keshav Memorial Technical Educational Society (KMTES)</a:t>
             </a:r>
             <a:r>
-              <a:rPr lang="en-US" sz="1050" b="1" u="none" strike="noStrike">
+              <a:rPr lang="en-US" sz="1050" b="1" u="none" strike="noStrike" dirty="0">
                 <a:solidFill>
                   <a:srgbClr val="000000"/>
                 </a:solidFill>
@@ -8371,10 +9511,10 @@
               <a:t> </a:t>
             </a:r>
             <a:br>
-              <a:rPr sz="1050"/>
+              <a:rPr sz="1050" dirty="0"/>
             </a:br>
             <a:r>
-              <a:rPr lang="en-US" sz="1600" b="1" u="none" strike="noStrike">
+              <a:rPr lang="en-US" sz="1600" b="1" u="none" strike="noStrike" dirty="0">
                 <a:solidFill>
                   <a:srgbClr val="000000"/>
                 </a:solidFill>
@@ -8385,7 +9525,7 @@
               </a:rPr>
               <a:t>(Approved by AICTE, New Delhi &amp; Affiliated to Osmania University, Hyderabad)</a:t>
             </a:r>
-            <a:endParaRPr lang="en-IN" sz="1600" b="0" u="none" strike="noStrike">
+            <a:endParaRPr lang="en-IN" sz="1600" b="0" u="none" strike="noStrike" dirty="0">
               <a:solidFill>
                 <a:srgbClr val="000000"/>
               </a:solidFill>
@@ -8897,7 +10037,7 @@
           <p:nvPr/>
         </p:nvPicPr>
         <p:blipFill>
-          <a:blip r:embed="rId2"/>
+          <a:blip r:embed="rId3"/>
           <a:stretch/>
         </p:blipFill>
         <p:spPr>
@@ -9030,570 +10170,6 @@
   <p:cSld>
     <p:spTree>
       <p:nvGrpSpPr>
-        <p:cNvPr id="1" name="">
-          <a:extLst>
-            <a:ext uri="{FF2B5EF4-FFF2-40B4-BE49-F238E27FC236}">
-              <a16:creationId xmlns:a16="http://schemas.microsoft.com/office/drawing/2014/main" id="{63BAA2D7-0EC1-2043-0B7D-493E08079E77}"/>
-            </a:ext>
-          </a:extLst>
-        </p:cNvPr>
-        <p:cNvGrpSpPr/>
-        <p:nvPr/>
-      </p:nvGrpSpPr>
-      <p:grpSpPr>
-        <a:xfrm>
-          <a:off x="0" y="0"/>
-          <a:ext cx="0" cy="0"/>
-          <a:chOff x="0" y="0"/>
-          <a:chExt cx="0" cy="0"/>
-        </a:xfrm>
-      </p:grpSpPr>
-      <p:sp>
-        <p:nvSpPr>
-          <p:cNvPr id="88" name="PlaceHolder 1">
-            <a:extLst>
-              <a:ext uri="{FF2B5EF4-FFF2-40B4-BE49-F238E27FC236}">
-                <a16:creationId xmlns:a16="http://schemas.microsoft.com/office/drawing/2014/main" id="{D6F6279F-F26F-B59B-0891-0523503EF4BF}"/>
-              </a:ext>
-            </a:extLst>
-          </p:cNvPr>
-          <p:cNvSpPr>
-            <a:spLocks noGrp="1"/>
-          </p:cNvSpPr>
-          <p:nvPr>
-            <p:ph type="title"/>
-          </p:nvPr>
-        </p:nvSpPr>
-        <p:spPr>
-          <a:prstGeom prst="rect">
-            <a:avLst/>
-          </a:prstGeom>
-          <a:noFill/>
-          <a:ln w="0">
-            <a:noFill/>
-          </a:ln>
-        </p:spPr>
-        <p:txBody>
-          <a:bodyPr lIns="91440" tIns="45720" rIns="91440" bIns="45720" anchor="ctr">
-            <a:normAutofit/>
-          </a:bodyPr>
-          <a:lstStyle/>
-          <a:p>
-            <a:pPr algn="ctr">
-              <a:lnSpc>
-                <a:spcPct val="100000"/>
-              </a:lnSpc>
-              <a:tabLst>
-                <a:tab pos="0" algn="l"/>
-              </a:tabLst>
-            </a:pPr>
-            <a:r>
-              <a:rPr lang="en-US" sz="3600" b="1" dirty="0">
-                <a:solidFill>
-                  <a:srgbClr val="780373"/>
-                </a:solidFill>
-                <a:latin typeface="Times New Roman"/>
-              </a:rPr>
-              <a:t>6.References</a:t>
-            </a:r>
-            <a:endParaRPr lang="en-IN" sz="3600" b="1" u="none" strike="noStrike" dirty="0">
-              <a:solidFill>
-                <a:srgbClr val="000000"/>
-              </a:solidFill>
-              <a:effectLst/>
-              <a:uFillTx/>
-              <a:latin typeface="Arial"/>
-            </a:endParaRPr>
-          </a:p>
-        </p:txBody>
-      </p:sp>
-      <p:sp>
-        <p:nvSpPr>
-          <p:cNvPr id="2" name="Slide Number Placeholder 1">
-            <a:extLst>
-              <a:ext uri="{FF2B5EF4-FFF2-40B4-BE49-F238E27FC236}">
-                <a16:creationId xmlns:a16="http://schemas.microsoft.com/office/drawing/2014/main" id="{77B0D8AC-B975-77B0-76F7-69CA5420A6A4}"/>
-              </a:ext>
-            </a:extLst>
-          </p:cNvPr>
-          <p:cNvSpPr>
-            <a:spLocks noGrp="1"/>
-          </p:cNvSpPr>
-          <p:nvPr>
-            <p:ph type="sldNum" idx="18"/>
-          </p:nvPr>
-        </p:nvSpPr>
-        <p:spPr/>
-        <p:txBody>
-          <a:bodyPr/>
-          <a:lstStyle/>
-          <a:p>
-            <a:pPr indent="0" algn="r" defTabSz="914400">
-              <a:lnSpc>
-                <a:spcPct val="100000"/>
-              </a:lnSpc>
-              <a:buNone/>
-              <a:tabLst>
-                <a:tab pos="0" algn="l"/>
-              </a:tabLst>
-            </a:pPr>
-            <a:fld id="{9118F6E7-F1DC-4F9F-A55D-F4F9EDAF9867}" type="slidenum">
-              <a:rPr lang="en-US" sz="1200" b="0" u="none" strike="noStrike" smtClean="0">
-                <a:solidFill>
-                  <a:schemeClr val="dk1">
-                    <a:tint val="75000"/>
-                  </a:schemeClr>
-                </a:solidFill>
-                <a:effectLst/>
-                <a:uFillTx/>
-                <a:latin typeface="Calibri"/>
-              </a:rPr>
-              <a:t>10</a:t>
-            </a:fld>
-            <a:endParaRPr lang="en-IN" sz="1200" b="0" u="none" strike="noStrike">
-              <a:solidFill>
-                <a:srgbClr val="000000"/>
-              </a:solidFill>
-              <a:effectLst/>
-              <a:uFillTx/>
-              <a:latin typeface="Times New Roman"/>
-            </a:endParaRPr>
-          </a:p>
-        </p:txBody>
-      </p:sp>
-      <p:sp>
-        <p:nvSpPr>
-          <p:cNvPr id="90" name="PlaceHolder 1">
-            <a:extLst>
-              <a:ext uri="{FF2B5EF4-FFF2-40B4-BE49-F238E27FC236}">
-                <a16:creationId xmlns:a16="http://schemas.microsoft.com/office/drawing/2014/main" id="{8A0B1B03-2A22-9A6D-2FEB-B3467A5200FE}"/>
-              </a:ext>
-            </a:extLst>
-          </p:cNvPr>
-          <p:cNvSpPr/>
-          <p:nvPr/>
-        </p:nvSpPr>
-        <p:spPr>
-          <a:xfrm>
-            <a:off x="115200" y="118440"/>
-            <a:ext cx="11960640" cy="338760"/>
-          </a:xfrm>
-          <a:prstGeom prst="rect">
-            <a:avLst/>
-          </a:prstGeom>
-          <a:noFill/>
-          <a:ln w="0">
-            <a:noFill/>
-          </a:ln>
-        </p:spPr>
-        <p:style>
-          <a:lnRef idx="0">
-            <a:scrgbClr r="0" g="0" b="0"/>
-          </a:lnRef>
-          <a:fillRef idx="0">
-            <a:scrgbClr r="0" g="0" b="0"/>
-          </a:fillRef>
-          <a:effectRef idx="0">
-            <a:scrgbClr r="0" g="0" b="0"/>
-          </a:effectRef>
-          <a:fontRef idx="minor"/>
-        </p:style>
-        <p:txBody>
-          <a:bodyPr lIns="90000" tIns="45000" rIns="90000" bIns="45000" anchor="ctr">
-            <a:normAutofit/>
-          </a:bodyPr>
-          <a:lstStyle/>
-          <a:p>
-            <a:pPr algn="ctr">
-              <a:tabLst>
-                <a:tab pos="0" algn="l"/>
-              </a:tabLst>
-            </a:pPr>
-            <a:r>
-              <a:rPr lang="en-US" sz="1600" b="0" u="none" strike="noStrike" dirty="0">
-                <a:solidFill>
-                  <a:schemeClr val="dk1"/>
-                </a:solidFill>
-                <a:effectLst/>
-                <a:uFillTx/>
-                <a:latin typeface="Times New Roman"/>
-              </a:rPr>
-              <a:t>Batch No. C6       										 	</a:t>
-            </a:r>
-            <a:r>
-              <a:rPr lang="en-US" sz="1600" b="1" dirty="0">
-                <a:latin typeface="Times New Roman"/>
-              </a:rPr>
-              <a:t>DCTM</a:t>
-            </a:r>
-            <a:endParaRPr lang="en-IN" sz="1600" b="0" u="none" strike="noStrike" dirty="0">
-              <a:solidFill>
-                <a:srgbClr val="000000"/>
-              </a:solidFill>
-              <a:effectLst/>
-              <a:uFillTx/>
-              <a:latin typeface="Arial"/>
-            </a:endParaRPr>
-          </a:p>
-        </p:txBody>
-      </p:sp>
-      <p:sp>
-        <p:nvSpPr>
-          <p:cNvPr id="5" name="Rectangle 3">
-            <a:extLst>
-              <a:ext uri="{FF2B5EF4-FFF2-40B4-BE49-F238E27FC236}">
-                <a16:creationId xmlns:a16="http://schemas.microsoft.com/office/drawing/2014/main" id="{CD28AE65-4C0F-A377-202A-5E5D182BD470}"/>
-              </a:ext>
-            </a:extLst>
-          </p:cNvPr>
-          <p:cNvSpPr>
-            <a:spLocks noChangeArrowheads="1"/>
-          </p:cNvSpPr>
-          <p:nvPr/>
-        </p:nvSpPr>
-        <p:spPr bwMode="auto">
-          <a:xfrm>
-            <a:off x="0" y="-184666"/>
-            <a:ext cx="184731" cy="369332"/>
-          </a:xfrm>
-          <a:prstGeom prst="rect">
-            <a:avLst/>
-          </a:prstGeom>
-          <a:noFill/>
-          <a:ln>
-            <a:noFill/>
-          </a:ln>
-          <a:effectLst/>
-          <a:extLst>
-            <a:ext uri="{909E8E84-426E-40DD-AFC4-6F175D3DCCD1}">
-              <a14:hiddenFill xmlns:a14="http://schemas.microsoft.com/office/drawing/2010/main">
-                <a:solidFill>
-                  <a:schemeClr val="accent1"/>
-                </a:solidFill>
-              </a14:hiddenFill>
-            </a:ext>
-            <a:ext uri="{91240B29-F687-4F45-9708-019B960494DF}">
-              <a14:hiddenLine xmlns:a14="http://schemas.microsoft.com/office/drawing/2010/main" w="9525">
-                <a:solidFill>
-                  <a:schemeClr val="tx1"/>
-                </a:solidFill>
-                <a:miter lim="800000"/>
-                <a:headEnd/>
-                <a:tailEnd/>
-              </a14:hiddenLine>
-            </a:ext>
-            <a:ext uri="{AF507438-7753-43E0-B8FC-AC1667EBCBE1}">
-              <a14:hiddenEffects xmlns:a14="http://schemas.microsoft.com/office/drawing/2010/main">
-                <a:effectLst>
-                  <a:outerShdw dist="35921" dir="2700000" algn="ctr" rotWithShape="0">
-                    <a:schemeClr val="bg2"/>
-                  </a:outerShdw>
-                </a:effectLst>
-              </a14:hiddenEffects>
-            </a:ext>
-          </a:extLst>
-        </p:spPr>
-        <p:txBody>
-          <a:bodyPr vert="horz" wrap="none" lIns="91440" tIns="45720" rIns="91440" bIns="45720" numCol="1" anchor="ctr" anchorCtr="0" compatLnSpc="1">
-            <a:prstTxWarp prst="textNoShape">
-              <a:avLst/>
-            </a:prstTxWarp>
-            <a:spAutoFit/>
-          </a:bodyPr>
-          <a:lstStyle/>
-          <a:p>
-            <a:pPr marL="0" marR="0" lvl="0" indent="0" algn="l" defTabSz="914400" rtl="0" eaLnBrk="0" fontAlgn="base" latinLnBrk="0" hangingPunct="0">
-              <a:lnSpc>
-                <a:spcPct val="100000"/>
-              </a:lnSpc>
-              <a:spcBef>
-                <a:spcPct val="0"/>
-              </a:spcBef>
-              <a:spcAft>
-                <a:spcPct val="0"/>
-              </a:spcAft>
-              <a:buClrTx/>
-              <a:buSzTx/>
-              <a:buFontTx/>
-              <a:buNone/>
-              <a:tabLst/>
-            </a:pPr>
-            <a:endParaRPr kumimoji="0" lang="en-US" altLang="en-US" sz="1800" b="0" i="0" u="none" strike="noStrike" cap="none" normalizeH="0" baseline="0" dirty="0">
-              <a:ln>
-                <a:noFill/>
-              </a:ln>
-              <a:solidFill>
-                <a:schemeClr val="tx1"/>
-              </a:solidFill>
-              <a:effectLst/>
-              <a:latin typeface="Arial" panose="020B0604020202020204" pitchFamily="34" charset="0"/>
-            </a:endParaRPr>
-          </a:p>
-        </p:txBody>
-      </p:sp>
-      <p:sp>
-        <p:nvSpPr>
-          <p:cNvPr id="15" name="Rectangle 6">
-            <a:extLst>
-              <a:ext uri="{FF2B5EF4-FFF2-40B4-BE49-F238E27FC236}">
-                <a16:creationId xmlns:a16="http://schemas.microsoft.com/office/drawing/2014/main" id="{8F2BD0C5-43C4-1845-1E4B-D80582CB1186}"/>
-              </a:ext>
-            </a:extLst>
-          </p:cNvPr>
-          <p:cNvSpPr>
-            <a:spLocks noGrp="1" noChangeArrowheads="1"/>
-          </p:cNvSpPr>
-          <p:nvPr>
-            <p:ph type="body"/>
-          </p:nvPr>
-        </p:nvSpPr>
-        <p:spPr bwMode="auto">
-          <a:xfrm>
-            <a:off x="431136" y="1887580"/>
-            <a:ext cx="11149704" cy="2677656"/>
-          </a:xfrm>
-          <a:prstGeom prst="rect">
-            <a:avLst/>
-          </a:prstGeom>
-          <a:noFill/>
-          <a:ln>
-            <a:noFill/>
-          </a:ln>
-          <a:effectLst/>
-          <a:extLst>
-            <a:ext uri="{909E8E84-426E-40DD-AFC4-6F175D3DCCD1}">
-              <a14:hiddenFill xmlns:a14="http://schemas.microsoft.com/office/drawing/2010/main">
-                <a:solidFill>
-                  <a:schemeClr val="accent1"/>
-                </a:solidFill>
-              </a14:hiddenFill>
-            </a:ext>
-            <a:ext uri="{91240B29-F687-4F45-9708-019B960494DF}">
-              <a14:hiddenLine xmlns:a14="http://schemas.microsoft.com/office/drawing/2010/main" w="9525">
-                <a:solidFill>
-                  <a:schemeClr val="tx1"/>
-                </a:solidFill>
-                <a:miter lim="800000"/>
-                <a:headEnd/>
-                <a:tailEnd/>
-              </a14:hiddenLine>
-            </a:ext>
-            <a:ext uri="{AF507438-7753-43E0-B8FC-AC1667EBCBE1}">
-              <a14:hiddenEffects xmlns:a14="http://schemas.microsoft.com/office/drawing/2010/main">
-                <a:effectLst>
-                  <a:outerShdw dist="35921" dir="2700000" algn="ctr" rotWithShape="0">
-                    <a:schemeClr val="bg2"/>
-                  </a:outerShdw>
-                </a:effectLst>
-              </a14:hiddenEffects>
-            </a:ext>
-          </a:extLst>
-        </p:spPr>
-        <p:txBody>
-          <a:bodyPr vert="horz" wrap="square" lIns="91440" tIns="45720" rIns="91440" bIns="45720" numCol="1" anchor="ctr" anchorCtr="0" compatLnSpc="1">
-            <a:prstTxWarp prst="textNoShape">
-              <a:avLst/>
-            </a:prstTxWarp>
-            <a:spAutoFit/>
-          </a:bodyPr>
-          <a:lstStyle/>
-          <a:p>
-            <a:pPr marL="457200" marR="0" lvl="0" indent="-457200" algn="just" defTabSz="914400" rtl="0" eaLnBrk="0" fontAlgn="base" latinLnBrk="0" hangingPunct="0">
-              <a:lnSpc>
-                <a:spcPct val="100000"/>
-              </a:lnSpc>
-              <a:spcBef>
-                <a:spcPct val="0"/>
-              </a:spcBef>
-              <a:spcAft>
-                <a:spcPct val="0"/>
-              </a:spcAft>
-              <a:buClrTx/>
-              <a:buSzTx/>
-              <a:buFont typeface="+mj-lt"/>
-              <a:buAutoNum type="arabicPeriod"/>
-              <a:tabLst/>
-            </a:pPr>
-            <a:endParaRPr kumimoji="0" lang="en-US" altLang="en-US" sz="2400" b="0" i="0" u="none" strike="noStrike" cap="none" normalizeH="0" baseline="0" dirty="0">
-              <a:ln>
-                <a:noFill/>
-              </a:ln>
-              <a:solidFill>
-                <a:schemeClr val="tx1"/>
-              </a:solidFill>
-              <a:effectLst/>
-              <a:latin typeface="Times New Roman" panose="02020603050405020304" pitchFamily="18" charset="0"/>
-              <a:cs typeface="Times New Roman" panose="02020603050405020304" pitchFamily="18" charset="0"/>
-            </a:endParaRPr>
-          </a:p>
-          <a:p>
-            <a:pPr marL="457200" indent="-457200" algn="just" eaLnBrk="0" fontAlgn="base" hangingPunct="0">
-              <a:lnSpc>
-                <a:spcPct val="100000"/>
-              </a:lnSpc>
-              <a:spcBef>
-                <a:spcPct val="0"/>
-              </a:spcBef>
-              <a:spcAft>
-                <a:spcPct val="0"/>
-              </a:spcAft>
-              <a:buFont typeface="+mj-lt"/>
-              <a:buAutoNum type="arabicPeriod"/>
-            </a:pPr>
-            <a:r>
-              <a:rPr kumimoji="0" lang="en-US" altLang="en-US" sz="2400" b="0" i="0" u="none" strike="noStrike" cap="none" normalizeH="0" baseline="0" dirty="0">
-                <a:ln>
-                  <a:noFill/>
-                </a:ln>
-                <a:solidFill>
-                  <a:schemeClr val="tx1"/>
-                </a:solidFill>
-                <a:effectLst/>
-                <a:latin typeface="Times New Roman" panose="02020603050405020304" pitchFamily="18" charset="0"/>
-                <a:cs typeface="Times New Roman" panose="02020603050405020304" pitchFamily="18" charset="0"/>
-              </a:rPr>
-              <a:t>DEMGAN: A Machine Learning-Based Intrusion Detection System Evasion Scheme.2025. </a:t>
-            </a:r>
-            <a:r>
-              <a:rPr kumimoji="0" lang="en-US" altLang="en-US" sz="2400" b="0" i="1" u="none" strike="noStrike" cap="none" normalizeH="0" baseline="0" dirty="0">
-                <a:ln>
-                  <a:noFill/>
-                </a:ln>
-                <a:solidFill>
-                  <a:schemeClr val="tx1"/>
-                </a:solidFill>
-                <a:effectLst/>
-                <a:latin typeface="Times New Roman" panose="02020603050405020304" pitchFamily="18" charset="0"/>
-                <a:cs typeface="Times New Roman" panose="02020603050405020304" pitchFamily="18" charset="0"/>
-              </a:rPr>
-              <a:t>(Base Paper)</a:t>
-            </a:r>
-            <a:r>
-              <a:rPr kumimoji="0" lang="en-US" altLang="en-US" sz="2400" b="0" i="0" u="none" strike="noStrike" cap="none" normalizeH="0" baseline="0" dirty="0">
-                <a:ln>
-                  <a:noFill/>
-                </a:ln>
-                <a:solidFill>
-                  <a:schemeClr val="tx1"/>
-                </a:solidFill>
-                <a:effectLst/>
-                <a:latin typeface="Times New Roman" panose="02020603050405020304" pitchFamily="18" charset="0"/>
-                <a:cs typeface="Times New Roman" panose="02020603050405020304" pitchFamily="18" charset="0"/>
-              </a:rPr>
-              <a:t> </a:t>
-            </a:r>
-          </a:p>
-          <a:p>
-            <a:pPr marL="457200" indent="-457200" algn="just" eaLnBrk="0" fontAlgn="base" hangingPunct="0">
-              <a:lnSpc>
-                <a:spcPct val="100000"/>
-              </a:lnSpc>
-              <a:spcBef>
-                <a:spcPct val="0"/>
-              </a:spcBef>
-              <a:spcAft>
-                <a:spcPct val="0"/>
-              </a:spcAft>
-              <a:buFont typeface="+mj-lt"/>
-              <a:buAutoNum type="arabicPeriod"/>
-            </a:pPr>
-            <a:r>
-              <a:rPr kumimoji="0" lang="en-US" altLang="en-US" sz="2400" b="0" i="0" u="none" strike="noStrike" cap="none" normalizeH="0" baseline="0" dirty="0">
-                <a:ln>
-                  <a:noFill/>
-                </a:ln>
-                <a:solidFill>
-                  <a:schemeClr val="tx1"/>
-                </a:solidFill>
-                <a:effectLst/>
-                <a:latin typeface="Times New Roman" panose="02020603050405020304" pitchFamily="18" charset="0"/>
-                <a:cs typeface="Times New Roman" panose="02020603050405020304" pitchFamily="18" charset="0"/>
-              </a:rPr>
-              <a:t>Wasserstein GAN. 2017. </a:t>
-            </a:r>
-          </a:p>
-          <a:p>
-            <a:pPr marL="457200" indent="-457200" algn="just" eaLnBrk="0" fontAlgn="base" hangingPunct="0">
-              <a:lnSpc>
-                <a:spcPct val="100000"/>
-              </a:lnSpc>
-              <a:spcBef>
-                <a:spcPct val="0"/>
-              </a:spcBef>
-              <a:spcAft>
-                <a:spcPct val="0"/>
-              </a:spcAft>
-              <a:buFont typeface="+mj-lt"/>
-              <a:buAutoNum type="arabicPeriod"/>
-            </a:pPr>
-            <a:r>
-              <a:rPr kumimoji="0" lang="en-US" altLang="en-US" sz="2400" b="0" i="0" u="none" strike="noStrike" cap="none" normalizeH="0" baseline="0" dirty="0">
-                <a:ln>
-                  <a:noFill/>
-                </a:ln>
-                <a:solidFill>
-                  <a:schemeClr val="tx1"/>
-                </a:solidFill>
-                <a:effectLst/>
-                <a:latin typeface="Times New Roman" panose="02020603050405020304" pitchFamily="18" charset="0"/>
-                <a:cs typeface="Times New Roman" panose="02020603050405020304" pitchFamily="18" charset="0"/>
-              </a:rPr>
-              <a:t>Identifying Relevant Features of CSE-CIC-IDS2018 Dataset for the Development of an Intrusion Detection System. 2023 .</a:t>
-            </a:r>
-          </a:p>
-          <a:p>
-            <a:pPr marL="457200" indent="-457200" algn="just" eaLnBrk="0" fontAlgn="base" hangingPunct="0">
-              <a:lnSpc>
-                <a:spcPct val="100000"/>
-              </a:lnSpc>
-              <a:spcBef>
-                <a:spcPct val="0"/>
-              </a:spcBef>
-              <a:spcAft>
-                <a:spcPct val="0"/>
-              </a:spcAft>
-              <a:buFont typeface="+mj-lt"/>
-              <a:buAutoNum type="arabicPeriod"/>
-            </a:pPr>
-            <a:r>
-              <a:rPr lang="en-IN" sz="2400" dirty="0">
-                <a:latin typeface="Times New Roman" panose="02020603050405020304" pitchFamily="18" charset="0"/>
-                <a:cs typeface="Times New Roman" panose="02020603050405020304" pitchFamily="18" charset="0"/>
-              </a:rPr>
-              <a:t>SMOTE: Synthetic Minority Over-sampling Technique. 2002.</a:t>
-            </a:r>
-            <a:endParaRPr kumimoji="0" lang="en-US" altLang="en-US" sz="2400" b="0" i="0" u="none" strike="noStrike" cap="none" normalizeH="0" baseline="0" dirty="0">
-              <a:ln>
-                <a:noFill/>
-              </a:ln>
-              <a:solidFill>
-                <a:schemeClr val="tx1"/>
-              </a:solidFill>
-              <a:effectLst/>
-              <a:latin typeface="Times New Roman" panose="02020603050405020304" pitchFamily="18" charset="0"/>
-              <a:cs typeface="Times New Roman" panose="02020603050405020304" pitchFamily="18" charset="0"/>
-            </a:endParaRPr>
-          </a:p>
-        </p:txBody>
-      </p:sp>
-    </p:spTree>
-    <p:extLst>
-      <p:ext uri="{BB962C8B-B14F-4D97-AF65-F5344CB8AC3E}">
-        <p14:creationId xmlns:p14="http://schemas.microsoft.com/office/powerpoint/2010/main" val="286242953"/>
-      </p:ext>
-    </p:extLst>
-  </p:cSld>
-  <p:clrMapOvr>
-    <a:masterClrMapping/>
-  </p:clrMapOvr>
-</p:sld>
-</file>
-
-<file path=ppt/slides/slide11.xml><?xml version="1.0" encoding="utf-8"?>
-<p:sld xmlns:a="http://schemas.openxmlformats.org/drawingml/2006/main" xmlns:r="http://schemas.openxmlformats.org/officeDocument/2006/relationships" xmlns:p="http://schemas.openxmlformats.org/presentationml/2006/main">
-  <p:cSld>
-    <p:spTree>
-      <p:nvGrpSpPr>
         <p:cNvPr id="1" name=""/>
         <p:cNvGrpSpPr/>
         <p:nvPr/>
@@ -9844,7 +10420,7 @@
                 <a:uFillTx/>
                 <a:latin typeface="Calibri"/>
               </a:rPr>
-              <a:t>11</a:t>
+              <a:t>10</a:t>
             </a:fld>
             <a:endParaRPr lang="en-IN" sz="1200" b="0" u="none" strike="noStrike">
               <a:solidFill>
@@ -10101,7 +10677,7 @@
         <p:spPr>
           <a:xfrm>
             <a:off x="1272508" y="1464359"/>
-            <a:ext cx="9646024" cy="3929281"/>
+            <a:ext cx="9646024" cy="3495829"/>
           </a:xfrm>
           <a:prstGeom prst="rect">
             <a:avLst/>
@@ -10305,32 +10881,6 @@
               </a:rPr>
               <a:t>Architecture </a:t>
             </a:r>
-            <a:endParaRPr lang="en-US" sz="2400" b="0" u="none" strike="noStrike" dirty="0">
-              <a:solidFill>
-                <a:schemeClr val="dk1"/>
-              </a:solidFill>
-              <a:effectLst/>
-              <a:uFillTx/>
-              <a:latin typeface="Times New Roman"/>
-            </a:endParaRPr>
-          </a:p>
-          <a:p>
-            <a:pPr marL="457200" indent="-457200" algn="just">
-              <a:lnSpc>
-                <a:spcPct val="100000"/>
-              </a:lnSpc>
-              <a:spcBef>
-                <a:spcPts val="479"/>
-              </a:spcBef>
-              <a:buClr>
-                <a:srgbClr val="000000"/>
-              </a:buClr>
-              <a:buFont typeface="Arial"/>
-              <a:buAutoNum type="arabicPeriod"/>
-              <a:tabLst>
-                <a:tab pos="0" algn="l"/>
-              </a:tabLst>
-            </a:pPr>
             <a:r>
               <a:rPr lang="en-US" sz="2400" b="0" u="none" strike="noStrike" dirty="0">
                 <a:solidFill>
@@ -10340,7 +10890,7 @@
                 <a:uFillTx/>
                 <a:latin typeface="Times New Roman"/>
               </a:rPr>
-              <a:t>Methodology	</a:t>
+              <a:t>	</a:t>
             </a:r>
           </a:p>
           <a:p>
@@ -10550,7 +11100,7 @@
                 <a:latin typeface="Times New Roman" panose="02020603050405020304" pitchFamily="18" charset="0"/>
                 <a:cs typeface="Times New Roman" panose="02020603050405020304" pitchFamily="18" charset="0"/>
               </a:rPr>
-              <a:t> : A Tabular Diffusion-based Adversarial Framework -introducing: (1) a Transformer-based Denoising Diffusion Model for stable generation, (2) SMOTE for class imbalance mitigation, and (3) Hybrid MI + SHAP feature selection expanding to 20 attributes.</a:t>
+              <a:t> : A Tabular Diffusion-based Adversarial Framework -introducing: (1) a Transformer-based Denoising Diffusion Model for stable generation, (2) SMOTE for class imbalance mitigation, and (3) MI + SHAP feature selection expanding to 20 attributes.</a:t>
             </a:r>
           </a:p>
           <a:p>
@@ -11058,15 +11608,24 @@
               <a:buChar char="•"/>
             </a:pPr>
             <a:r>
-              <a:rPr lang="en-US" sz="2200" dirty="0"/>
+              <a:rPr lang="en-US" sz="2200" dirty="0">
+                <a:latin typeface="Times New Roman" panose="02020603050405020304" pitchFamily="18" charset="0"/>
+                <a:cs typeface="Times New Roman" panose="02020603050405020304" pitchFamily="18" charset="0"/>
+              </a:rPr>
               <a:t>Modern networks face constant threats: DDoS, </a:t>
             </a:r>
             <a:r>
-              <a:rPr lang="en-US" sz="2200" dirty="0" err="1"/>
+              <a:rPr lang="en-US" sz="2200" dirty="0" err="1">
+                <a:latin typeface="Times New Roman" panose="02020603050405020304" pitchFamily="18" charset="0"/>
+                <a:cs typeface="Times New Roman" panose="02020603050405020304" pitchFamily="18" charset="0"/>
+              </a:rPr>
               <a:t>PortScan</a:t>
             </a:r>
             <a:r>
-              <a:rPr lang="en-US" sz="2200" dirty="0"/>
+              <a:rPr lang="en-US" sz="2200" dirty="0">
+                <a:latin typeface="Times New Roman" panose="02020603050405020304" pitchFamily="18" charset="0"/>
+                <a:cs typeface="Times New Roman" panose="02020603050405020304" pitchFamily="18" charset="0"/>
+              </a:rPr>
               <a:t>, SQL Injection, Brute Force, Botnets.</a:t>
             </a:r>
           </a:p>
@@ -11076,7 +11635,10 @@
               <a:buChar char="•"/>
             </a:pPr>
             <a:r>
-              <a:rPr lang="en-US" sz="2200" dirty="0"/>
+              <a:rPr lang="en-US" sz="2200" dirty="0">
+                <a:latin typeface="Times New Roman" panose="02020603050405020304" pitchFamily="18" charset="0"/>
+                <a:cs typeface="Times New Roman" panose="02020603050405020304" pitchFamily="18" charset="0"/>
+              </a:rPr>
               <a:t>ML-based Intrusion Detection Systems (IDS) classify network flows as Benign or Malicious.</a:t>
             </a:r>
           </a:p>
@@ -11086,7 +11648,10 @@
               <a:buChar char="•"/>
             </a:pPr>
             <a:r>
-              <a:rPr lang="en-US" sz="2200" dirty="0"/>
+              <a:rPr lang="en-US" sz="2200" dirty="0">
+                <a:latin typeface="Times New Roman" panose="02020603050405020304" pitchFamily="18" charset="0"/>
+                <a:cs typeface="Times New Roman" panose="02020603050405020304" pitchFamily="18" charset="0"/>
+              </a:rPr>
               <a:t>IDS models (DT, RF, MLP, CNN, etc.) perform well on benchmark datasets.</a:t>
             </a:r>
           </a:p>
@@ -11096,11 +11661,17 @@
               <a:buChar char="•"/>
             </a:pPr>
             <a:r>
-              <a:rPr lang="en-US" sz="2200" b="1" dirty="0"/>
+              <a:rPr lang="en-US" sz="2200" b="1" dirty="0">
+                <a:latin typeface="Times New Roman" panose="02020603050405020304" pitchFamily="18" charset="0"/>
+                <a:cs typeface="Times New Roman" panose="02020603050405020304" pitchFamily="18" charset="0"/>
+              </a:rPr>
               <a:t>Problem:</a:t>
             </a:r>
             <a:r>
-              <a:rPr lang="en-US" sz="2200" dirty="0"/>
+              <a:rPr lang="en-US" sz="2200" dirty="0">
+                <a:latin typeface="Times New Roman" panose="02020603050405020304" pitchFamily="18" charset="0"/>
+                <a:cs typeface="Times New Roman" panose="02020603050405020304" pitchFamily="18" charset="0"/>
+              </a:rPr>
               <a:t> ML models are NOT robust to adversarial inputs - crafted samples that fool the classifier.</a:t>
             </a:r>
           </a:p>
@@ -11110,11 +11681,17 @@
               <a:buChar char="•"/>
             </a:pPr>
             <a:r>
-              <a:rPr lang="en-US" sz="2200" b="1" dirty="0"/>
+              <a:rPr lang="en-US" sz="2200" b="1" dirty="0">
+                <a:latin typeface="Times New Roman" panose="02020603050405020304" pitchFamily="18" charset="0"/>
+                <a:cs typeface="Times New Roman" panose="02020603050405020304" pitchFamily="18" charset="0"/>
+              </a:rPr>
               <a:t>Adversarial Traffic:</a:t>
             </a:r>
             <a:r>
-              <a:rPr lang="en-US" sz="2200" dirty="0"/>
+              <a:rPr lang="en-US" sz="2200" dirty="0">
+                <a:latin typeface="Times New Roman" panose="02020603050405020304" pitchFamily="18" charset="0"/>
+                <a:cs typeface="Times New Roman" panose="02020603050405020304" pitchFamily="18" charset="0"/>
+              </a:rPr>
               <a:t> a malicious flow modified so the IDS labels it as "Benign" — this is an evasion attack.</a:t>
             </a:r>
           </a:p>
@@ -11124,7 +11701,10 @@
               <a:buChar char="•"/>
             </a:pPr>
             <a:r>
-              <a:rPr lang="en-US" sz="2200" dirty="0"/>
+              <a:rPr lang="en-US" sz="2200" dirty="0">
+                <a:latin typeface="Times New Roman" panose="02020603050405020304" pitchFamily="18" charset="0"/>
+                <a:cs typeface="Times New Roman" panose="02020603050405020304" pitchFamily="18" charset="0"/>
+              </a:rPr>
               <a:t>To evaluate IDS robustness, security teams need adversarial generators.</a:t>
             </a:r>
           </a:p>
@@ -11134,11 +11714,17 @@
               <a:buChar char="•"/>
             </a:pPr>
             <a:r>
-              <a:rPr lang="en-US" sz="2200" b="1" dirty="0"/>
+              <a:rPr lang="en-US" sz="2200" b="1" dirty="0">
+                <a:latin typeface="Times New Roman" panose="02020603050405020304" pitchFamily="18" charset="0"/>
+                <a:cs typeface="Times New Roman" panose="02020603050405020304" pitchFamily="18" charset="0"/>
+              </a:rPr>
               <a:t>DEMGAN (CMC, 2025)</a:t>
             </a:r>
             <a:r>
-              <a:rPr lang="en-US" sz="2200" dirty="0"/>
+              <a:rPr lang="en-US" sz="2200" dirty="0">
+                <a:latin typeface="Times New Roman" panose="02020603050405020304" pitchFamily="18" charset="0"/>
+                <a:cs typeface="Times New Roman" panose="02020603050405020304" pitchFamily="18" charset="0"/>
+              </a:rPr>
               <a:t> is the current state-of-the-art generator — uses Wasserstein GAN.</a:t>
             </a:r>
           </a:p>
@@ -11148,7 +11734,10 @@
               <a:buChar char="•"/>
             </a:pPr>
             <a:r>
-              <a:rPr lang="en-US" sz="2200" dirty="0"/>
+              <a:rPr lang="en-US" sz="2200" dirty="0">
+                <a:latin typeface="Times New Roman" panose="02020603050405020304" pitchFamily="18" charset="0"/>
+                <a:cs typeface="Times New Roman" panose="02020603050405020304" pitchFamily="18" charset="0"/>
+              </a:rPr>
               <a:t>DCTM improves on DEMGAN using Diffusion Models — more stable, more comprehensive.</a:t>
             </a:r>
           </a:p>
@@ -11158,23 +11747,38 @@
               <a:buChar char="•"/>
             </a:pPr>
             <a:r>
-              <a:rPr lang="en-US" sz="2200" dirty="0"/>
+              <a:rPr lang="en-US" sz="2200" dirty="0">
+                <a:latin typeface="Times New Roman" panose="02020603050405020304" pitchFamily="18" charset="0"/>
+                <a:cs typeface="Times New Roman" panose="02020603050405020304" pitchFamily="18" charset="0"/>
+              </a:rPr>
               <a:t>Dual-use: DCTM is both an </a:t>
             </a:r>
             <a:r>
-              <a:rPr lang="en-US" sz="2200" b="1" dirty="0"/>
+              <a:rPr lang="en-US" sz="2200" b="1" dirty="0">
+                <a:latin typeface="Times New Roman" panose="02020603050405020304" pitchFamily="18" charset="0"/>
+                <a:cs typeface="Times New Roman" panose="02020603050405020304" pitchFamily="18" charset="0"/>
+              </a:rPr>
               <a:t>attack tool</a:t>
             </a:r>
             <a:r>
-              <a:rPr lang="en-US" sz="2200" dirty="0"/>
+              <a:rPr lang="en-US" sz="2200" dirty="0">
+                <a:latin typeface="Times New Roman" panose="02020603050405020304" pitchFamily="18" charset="0"/>
+                <a:cs typeface="Times New Roman" panose="02020603050405020304" pitchFamily="18" charset="0"/>
+              </a:rPr>
               <a:t> (evasion) and a </a:t>
             </a:r>
             <a:r>
-              <a:rPr lang="en-US" sz="2200" b="1" dirty="0"/>
+              <a:rPr lang="en-US" sz="2200" b="1" dirty="0">
+                <a:latin typeface="Times New Roman" panose="02020603050405020304" pitchFamily="18" charset="0"/>
+                <a:cs typeface="Times New Roman" panose="02020603050405020304" pitchFamily="18" charset="0"/>
+              </a:rPr>
               <a:t>defense tool</a:t>
             </a:r>
             <a:r>
-              <a:rPr lang="en-US" sz="2200" dirty="0"/>
+              <a:rPr lang="en-US" sz="2200" dirty="0">
+                <a:latin typeface="Times New Roman" panose="02020603050405020304" pitchFamily="18" charset="0"/>
+                <a:cs typeface="Times New Roman" panose="02020603050405020304" pitchFamily="18" charset="0"/>
+              </a:rPr>
               <a:t> (adversarial retraining).</a:t>
             </a:r>
           </a:p>
@@ -12057,41 +12661,42 @@
           </a:p>
         </p:txBody>
       </p:sp>
-      <p:sp>
-        <p:nvSpPr>
-          <p:cNvPr id="10" name="TextBox 9">
+      <p:pic>
+        <p:nvPicPr>
+          <p:cNvPr id="4" name="Picture 3">
             <a:extLst>
               <a:ext uri="{FF2B5EF4-FFF2-40B4-BE49-F238E27FC236}">
-                <a16:creationId xmlns:a16="http://schemas.microsoft.com/office/drawing/2014/main" id="{F13A7EFF-15BE-AE00-B52D-0694D0899207}"/>
+                <a16:creationId xmlns:a16="http://schemas.microsoft.com/office/drawing/2014/main" id="{4FAC8CA1-8710-94FF-AAE1-6547D708018A}"/>
               </a:ext>
             </a:extLst>
           </p:cNvPr>
-          <p:cNvSpPr txBox="1"/>
+          <p:cNvPicPr>
+            <a:picLocks noChangeAspect="1"/>
+          </p:cNvPicPr>
           <p:nvPr/>
-        </p:nvSpPr>
+        </p:nvPicPr>
+        <p:blipFill>
+          <a:blip r:embed="rId3">
+            <a:extLst>
+              <a:ext uri="{28A0092B-C50C-407E-A947-70E740481C1C}">
+                <a14:useLocalDpi xmlns:a14="http://schemas.microsoft.com/office/drawing/2010/main" val="0"/>
+              </a:ext>
+            </a:extLst>
+          </a:blip>
+          <a:stretch>
+            <a:fillRect/>
+          </a:stretch>
+        </p:blipFill>
         <p:spPr>
           <a:xfrm>
-            <a:off x="3038475" y="2095500"/>
-            <a:ext cx="469809" cy="369332"/>
+            <a:off x="1416424" y="1190858"/>
+            <a:ext cx="9716901" cy="5253200"/>
           </a:xfrm>
           <a:prstGeom prst="rect">
             <a:avLst/>
           </a:prstGeom>
-          <a:noFill/>
         </p:spPr>
-        <p:txBody>
-          <a:bodyPr wrap="none" rtlCol="0">
-            <a:spAutoFit/>
-          </a:bodyPr>
-          <a:lstStyle/>
-          <a:p>
-            <a:r>
-              <a:rPr lang="en-IN" dirty="0"/>
-              <a:t>arc</a:t>
-            </a:r>
-          </a:p>
-        </p:txBody>
-      </p:sp>
+      </p:pic>
     </p:spTree>
     <p:extLst>
       <p:ext uri="{BB962C8B-B14F-4D97-AF65-F5344CB8AC3E}">
@@ -12420,6 +13025,48 @@
           </a:p>
         </p:txBody>
       </p:sp>
+      <p:sp>
+        <p:nvSpPr>
+          <p:cNvPr id="4" name="TextBox 3">
+            <a:extLst>
+              <a:ext uri="{FF2B5EF4-FFF2-40B4-BE49-F238E27FC236}">
+                <a16:creationId xmlns:a16="http://schemas.microsoft.com/office/drawing/2014/main" id="{54BA33E1-0E8F-ED74-81BB-99F6A071CFF4}"/>
+              </a:ext>
+            </a:extLst>
+          </p:cNvPr>
+          <p:cNvSpPr txBox="1"/>
+          <p:nvPr/>
+        </p:nvSpPr>
+        <p:spPr>
+          <a:xfrm>
+            <a:off x="5378617" y="2562721"/>
+            <a:ext cx="1433085" cy="369332"/>
+          </a:xfrm>
+          <a:prstGeom prst="rect">
+            <a:avLst/>
+          </a:prstGeom>
+          <a:noFill/>
+        </p:spPr>
+        <p:txBody>
+          <a:bodyPr wrap="none" rtlCol="0">
+            <a:spAutoFit/>
+          </a:bodyPr>
+          <a:lstStyle/>
+          <a:p>
+            <a:r>
+              <a:rPr lang="en-US" b="1" dirty="0">
+                <a:solidFill>
+                  <a:srgbClr val="780373"/>
+                </a:solidFill>
+                <a:latin typeface="Times New Roman"/>
+                <a:hlinkClick r:id="rId3" action="ppaction://hlinkfile"/>
+              </a:rPr>
+              <a:t>Architecture</a:t>
+            </a:r>
+            <a:endParaRPr lang="en-IN" dirty="0"/>
+          </a:p>
+        </p:txBody>
+      </p:sp>
     </p:spTree>
     <p:extLst>
       <p:ext uri="{BB962C8B-B14F-4D97-AF65-F5344CB8AC3E}">
@@ -12434,531 +13081,6 @@
 </file>
 
 <file path=ppt/slides/slide8.xml><?xml version="1.0" encoding="utf-8"?>
-<p:sld xmlns:a="http://schemas.openxmlformats.org/drawingml/2006/main" xmlns:r="http://schemas.openxmlformats.org/officeDocument/2006/relationships" xmlns:p="http://schemas.openxmlformats.org/presentationml/2006/main">
-  <p:cSld>
-    <p:spTree>
-      <p:nvGrpSpPr>
-        <p:cNvPr id="1" name="">
-          <a:extLst>
-            <a:ext uri="{FF2B5EF4-FFF2-40B4-BE49-F238E27FC236}">
-              <a16:creationId xmlns:a16="http://schemas.microsoft.com/office/drawing/2014/main" id="{1618B7DE-0166-FF80-DE06-751019C9AE8C}"/>
-            </a:ext>
-          </a:extLst>
-        </p:cNvPr>
-        <p:cNvGrpSpPr/>
-        <p:nvPr/>
-      </p:nvGrpSpPr>
-      <p:grpSpPr>
-        <a:xfrm>
-          <a:off x="0" y="0"/>
-          <a:ext cx="0" cy="0"/>
-          <a:chOff x="0" y="0"/>
-          <a:chExt cx="0" cy="0"/>
-        </a:xfrm>
-      </p:grpSpPr>
-      <p:sp>
-        <p:nvSpPr>
-          <p:cNvPr id="88" name="PlaceHolder 1">
-            <a:extLst>
-              <a:ext uri="{FF2B5EF4-FFF2-40B4-BE49-F238E27FC236}">
-                <a16:creationId xmlns:a16="http://schemas.microsoft.com/office/drawing/2014/main" id="{C0C1446E-608B-206F-B294-B9945E218A20}"/>
-              </a:ext>
-            </a:extLst>
-          </p:cNvPr>
-          <p:cNvSpPr>
-            <a:spLocks noGrp="1"/>
-          </p:cNvSpPr>
-          <p:nvPr>
-            <p:ph type="title"/>
-          </p:nvPr>
-        </p:nvSpPr>
-        <p:spPr>
-          <a:xfrm>
-            <a:off x="746640" y="274680"/>
-            <a:ext cx="10697040" cy="1141560"/>
-          </a:xfrm>
-          <a:prstGeom prst="rect">
-            <a:avLst/>
-          </a:prstGeom>
-          <a:noFill/>
-          <a:ln w="0">
-            <a:noFill/>
-          </a:ln>
-        </p:spPr>
-        <p:txBody>
-          <a:bodyPr lIns="91440" tIns="45720" rIns="91440" bIns="45720" anchor="ctr">
-            <a:normAutofit/>
-          </a:bodyPr>
-          <a:lstStyle/>
-          <a:p>
-            <a:pPr algn="ctr">
-              <a:lnSpc>
-                <a:spcPct val="100000"/>
-              </a:lnSpc>
-              <a:tabLst>
-                <a:tab pos="0" algn="l"/>
-              </a:tabLst>
-            </a:pPr>
-            <a:r>
-              <a:rPr lang="en-US" sz="3600" b="1" dirty="0">
-                <a:solidFill>
-                  <a:srgbClr val="780373"/>
-                </a:solidFill>
-                <a:latin typeface="Times New Roman"/>
-              </a:rPr>
-              <a:t>6.Methodology</a:t>
-            </a:r>
-            <a:endParaRPr lang="en-IN" sz="3600" b="1" u="none" strike="noStrike" dirty="0">
-              <a:solidFill>
-                <a:srgbClr val="000000"/>
-              </a:solidFill>
-              <a:effectLst/>
-              <a:uFillTx/>
-              <a:latin typeface="Arial"/>
-            </a:endParaRPr>
-          </a:p>
-        </p:txBody>
-      </p:sp>
-      <p:sp>
-        <p:nvSpPr>
-          <p:cNvPr id="90" name="PlaceHolder 1">
-            <a:extLst>
-              <a:ext uri="{FF2B5EF4-FFF2-40B4-BE49-F238E27FC236}">
-                <a16:creationId xmlns:a16="http://schemas.microsoft.com/office/drawing/2014/main" id="{F97A1D1E-5DE1-1A2B-D581-FC38C1386DA1}"/>
-              </a:ext>
-            </a:extLst>
-          </p:cNvPr>
-          <p:cNvSpPr/>
-          <p:nvPr/>
-        </p:nvSpPr>
-        <p:spPr>
-          <a:xfrm>
-            <a:off x="115200" y="118440"/>
-            <a:ext cx="11960640" cy="338760"/>
-          </a:xfrm>
-          <a:prstGeom prst="rect">
-            <a:avLst/>
-          </a:prstGeom>
-          <a:noFill/>
-          <a:ln w="0">
-            <a:noFill/>
-          </a:ln>
-        </p:spPr>
-        <p:style>
-          <a:lnRef idx="0">
-            <a:scrgbClr r="0" g="0" b="0"/>
-          </a:lnRef>
-          <a:fillRef idx="0">
-            <a:scrgbClr r="0" g="0" b="0"/>
-          </a:fillRef>
-          <a:effectRef idx="0">
-            <a:scrgbClr r="0" g="0" b="0"/>
-          </a:effectRef>
-          <a:fontRef idx="minor"/>
-        </p:style>
-        <p:txBody>
-          <a:bodyPr lIns="90000" tIns="45000" rIns="90000" bIns="45000" anchor="ctr">
-            <a:normAutofit/>
-          </a:bodyPr>
-          <a:lstStyle/>
-          <a:p>
-            <a:pPr algn="ctr">
-              <a:tabLst>
-                <a:tab pos="0" algn="l"/>
-              </a:tabLst>
-            </a:pPr>
-            <a:r>
-              <a:rPr lang="en-US" sz="1600" b="0" u="none" strike="noStrike" dirty="0">
-                <a:solidFill>
-                  <a:schemeClr val="dk1"/>
-                </a:solidFill>
-                <a:effectLst/>
-                <a:uFillTx/>
-                <a:latin typeface="Times New Roman"/>
-              </a:rPr>
-              <a:t>Batch No. C6       										</a:t>
-            </a:r>
-            <a:r>
-              <a:rPr lang="en-US" sz="1600" b="1" dirty="0">
-                <a:latin typeface="Times New Roman"/>
-              </a:rPr>
-              <a:t> 	DCTM</a:t>
-            </a:r>
-            <a:endParaRPr lang="en-IN" sz="1600" b="0" u="none" strike="noStrike" dirty="0">
-              <a:solidFill>
-                <a:srgbClr val="000000"/>
-              </a:solidFill>
-              <a:effectLst/>
-              <a:uFillTx/>
-              <a:latin typeface="Arial"/>
-            </a:endParaRPr>
-          </a:p>
-        </p:txBody>
-      </p:sp>
-      <p:sp>
-        <p:nvSpPr>
-          <p:cNvPr id="2" name="Slide Number Placeholder 1">
-            <a:extLst>
-              <a:ext uri="{FF2B5EF4-FFF2-40B4-BE49-F238E27FC236}">
-                <a16:creationId xmlns:a16="http://schemas.microsoft.com/office/drawing/2014/main" id="{E9934C75-F2E5-5F2B-28EA-AA6B46752784}"/>
-              </a:ext>
-            </a:extLst>
-          </p:cNvPr>
-          <p:cNvSpPr>
-            <a:spLocks noGrp="1"/>
-          </p:cNvSpPr>
-          <p:nvPr>
-            <p:ph type="sldNum" idx="12"/>
-          </p:nvPr>
-        </p:nvSpPr>
-        <p:spPr/>
-        <p:txBody>
-          <a:bodyPr/>
-          <a:lstStyle/>
-          <a:p>
-            <a:pPr indent="0" algn="r" defTabSz="914400">
-              <a:lnSpc>
-                <a:spcPct val="100000"/>
-              </a:lnSpc>
-              <a:buNone/>
-              <a:tabLst>
-                <a:tab pos="0" algn="l"/>
-              </a:tabLst>
-            </a:pPr>
-            <a:fld id="{9118F6E7-F1DC-4F9F-A55D-F4F9EDAF9867}" type="slidenum">
-              <a:rPr lang="en-US" sz="1200" b="0" u="none" strike="noStrike" smtClean="0">
-                <a:solidFill>
-                  <a:schemeClr val="dk1">
-                    <a:tint val="75000"/>
-                  </a:schemeClr>
-                </a:solidFill>
-                <a:effectLst/>
-                <a:uFillTx/>
-                <a:latin typeface="Calibri"/>
-              </a:rPr>
-              <a:t>8</a:t>
-            </a:fld>
-            <a:endParaRPr lang="en-IN" sz="1200" b="0" u="none" strike="noStrike">
-              <a:solidFill>
-                <a:srgbClr val="000000"/>
-              </a:solidFill>
-              <a:effectLst/>
-              <a:uFillTx/>
-              <a:latin typeface="Times New Roman"/>
-            </a:endParaRPr>
-          </a:p>
-        </p:txBody>
-      </p:sp>
-      <p:sp>
-        <p:nvSpPr>
-          <p:cNvPr id="5" name="Rectangle 3">
-            <a:extLst>
-              <a:ext uri="{FF2B5EF4-FFF2-40B4-BE49-F238E27FC236}">
-                <a16:creationId xmlns:a16="http://schemas.microsoft.com/office/drawing/2014/main" id="{9378B2A1-F941-F3B2-5398-98572380A87F}"/>
-              </a:ext>
-            </a:extLst>
-          </p:cNvPr>
-          <p:cNvSpPr>
-            <a:spLocks noChangeArrowheads="1"/>
-          </p:cNvSpPr>
-          <p:nvPr/>
-        </p:nvSpPr>
-        <p:spPr bwMode="auto">
-          <a:xfrm>
-            <a:off x="0" y="-184666"/>
-            <a:ext cx="184731" cy="369332"/>
-          </a:xfrm>
-          <a:prstGeom prst="rect">
-            <a:avLst/>
-          </a:prstGeom>
-          <a:noFill/>
-          <a:ln>
-            <a:noFill/>
-          </a:ln>
-          <a:effectLst/>
-          <a:extLst>
-            <a:ext uri="{909E8E84-426E-40DD-AFC4-6F175D3DCCD1}">
-              <a14:hiddenFill xmlns:a14="http://schemas.microsoft.com/office/drawing/2010/main">
-                <a:solidFill>
-                  <a:schemeClr val="accent1"/>
-                </a:solidFill>
-              </a14:hiddenFill>
-            </a:ext>
-            <a:ext uri="{91240B29-F687-4F45-9708-019B960494DF}">
-              <a14:hiddenLine xmlns:a14="http://schemas.microsoft.com/office/drawing/2010/main" w="9525">
-                <a:solidFill>
-                  <a:schemeClr val="tx1"/>
-                </a:solidFill>
-                <a:miter lim="800000"/>
-                <a:headEnd/>
-                <a:tailEnd/>
-              </a14:hiddenLine>
-            </a:ext>
-            <a:ext uri="{AF507438-7753-43E0-B8FC-AC1667EBCBE1}">
-              <a14:hiddenEffects xmlns:a14="http://schemas.microsoft.com/office/drawing/2010/main">
-                <a:effectLst>
-                  <a:outerShdw dist="35921" dir="2700000" algn="ctr" rotWithShape="0">
-                    <a:schemeClr val="bg2"/>
-                  </a:outerShdw>
-                </a:effectLst>
-              </a14:hiddenEffects>
-            </a:ext>
-          </a:extLst>
-        </p:spPr>
-        <p:txBody>
-          <a:bodyPr vert="horz" wrap="none" lIns="91440" tIns="45720" rIns="91440" bIns="45720" numCol="1" anchor="ctr" anchorCtr="0" compatLnSpc="1">
-            <a:prstTxWarp prst="textNoShape">
-              <a:avLst/>
-            </a:prstTxWarp>
-            <a:spAutoFit/>
-          </a:bodyPr>
-          <a:lstStyle/>
-          <a:p>
-            <a:pPr marL="0" marR="0" lvl="0" indent="0" algn="l" defTabSz="914400" rtl="0" eaLnBrk="0" fontAlgn="base" latinLnBrk="0" hangingPunct="0">
-              <a:lnSpc>
-                <a:spcPct val="100000"/>
-              </a:lnSpc>
-              <a:spcBef>
-                <a:spcPct val="0"/>
-              </a:spcBef>
-              <a:spcAft>
-                <a:spcPct val="0"/>
-              </a:spcAft>
-              <a:buClrTx/>
-              <a:buSzTx/>
-              <a:buFontTx/>
-              <a:buNone/>
-              <a:tabLst/>
-            </a:pPr>
-            <a:endParaRPr kumimoji="0" lang="en-US" altLang="en-US" sz="1800" b="0" i="0" u="none" strike="noStrike" cap="none" normalizeH="0" baseline="0" dirty="0">
-              <a:ln>
-                <a:noFill/>
-              </a:ln>
-              <a:solidFill>
-                <a:schemeClr val="tx1"/>
-              </a:solidFill>
-              <a:effectLst/>
-              <a:latin typeface="Arial" panose="020B0604020202020204" pitchFamily="34" charset="0"/>
-            </a:endParaRPr>
-          </a:p>
-        </p:txBody>
-      </p:sp>
-      <p:sp>
-        <p:nvSpPr>
-          <p:cNvPr id="7" name="TextBox 6">
-            <a:extLst>
-              <a:ext uri="{FF2B5EF4-FFF2-40B4-BE49-F238E27FC236}">
-                <a16:creationId xmlns:a16="http://schemas.microsoft.com/office/drawing/2014/main" id="{894F1589-FCDF-D310-CC18-092A43AB7B3B}"/>
-              </a:ext>
-            </a:extLst>
-          </p:cNvPr>
-          <p:cNvSpPr txBox="1"/>
-          <p:nvPr/>
-        </p:nvSpPr>
-        <p:spPr>
-          <a:xfrm>
-            <a:off x="942695" y="1213785"/>
-            <a:ext cx="10304929" cy="5324535"/>
-          </a:xfrm>
-          <a:prstGeom prst="rect">
-            <a:avLst/>
-          </a:prstGeom>
-          <a:noFill/>
-        </p:spPr>
-        <p:txBody>
-          <a:bodyPr wrap="square">
-            <a:spAutoFit/>
-          </a:bodyPr>
-          <a:lstStyle/>
-          <a:p>
-            <a:r>
-              <a:rPr lang="en-IN" sz="2000" b="1" dirty="0">
-                <a:latin typeface="Times New Roman" panose="02020603050405020304" pitchFamily="18" charset="0"/>
-                <a:cs typeface="Times New Roman" panose="02020603050405020304" pitchFamily="18" charset="0"/>
-              </a:rPr>
-              <a:t>Modules:</a:t>
-            </a:r>
-            <a:endParaRPr lang="en-IN" sz="2000" dirty="0">
-              <a:latin typeface="Times New Roman" panose="02020603050405020304" pitchFamily="18" charset="0"/>
-              <a:cs typeface="Times New Roman" panose="02020603050405020304" pitchFamily="18" charset="0"/>
-            </a:endParaRPr>
-          </a:p>
-          <a:p>
-            <a:r>
-              <a:rPr lang="en-IN" sz="2000" dirty="0">
-                <a:latin typeface="Times New Roman" panose="02020603050405020304" pitchFamily="18" charset="0"/>
-                <a:cs typeface="Times New Roman" panose="02020603050405020304" pitchFamily="18" charset="0"/>
-              </a:rPr>
-              <a:t>Data Preprocessing Module</a:t>
-            </a:r>
-          </a:p>
-          <a:p>
-            <a:r>
-              <a:rPr lang="en-IN" sz="2000" dirty="0">
-                <a:latin typeface="Times New Roman" panose="02020603050405020304" pitchFamily="18" charset="0"/>
-                <a:cs typeface="Times New Roman" panose="02020603050405020304" pitchFamily="18" charset="0"/>
-              </a:rPr>
-              <a:t>Adaptive Feature Selection Module</a:t>
-            </a:r>
-          </a:p>
-          <a:p>
-            <a:r>
-              <a:rPr lang="en-IN" sz="2000" dirty="0">
-                <a:latin typeface="Times New Roman" panose="02020603050405020304" pitchFamily="18" charset="0"/>
-                <a:cs typeface="Times New Roman" panose="02020603050405020304" pitchFamily="18" charset="0"/>
-              </a:rPr>
-              <a:t>Diffusion Model Training Module (</a:t>
-            </a:r>
-            <a:r>
-              <a:rPr lang="en-IN" sz="2000" dirty="0" err="1">
-                <a:latin typeface="Times New Roman" panose="02020603050405020304" pitchFamily="18" charset="0"/>
-                <a:cs typeface="Times New Roman" panose="02020603050405020304" pitchFamily="18" charset="0"/>
-              </a:rPr>
-              <a:t>DiffEvasion</a:t>
-            </a:r>
-            <a:r>
-              <a:rPr lang="en-IN" sz="2000" dirty="0">
-                <a:latin typeface="Times New Roman" panose="02020603050405020304" pitchFamily="18" charset="0"/>
-                <a:cs typeface="Times New Roman" panose="02020603050405020304" pitchFamily="18" charset="0"/>
-              </a:rPr>
-              <a:t>)</a:t>
-            </a:r>
-          </a:p>
-          <a:p>
-            <a:r>
-              <a:rPr lang="en-IN" sz="2000" dirty="0">
-                <a:latin typeface="Times New Roman" panose="02020603050405020304" pitchFamily="18" charset="0"/>
-                <a:cs typeface="Times New Roman" panose="02020603050405020304" pitchFamily="18" charset="0"/>
-              </a:rPr>
-              <a:t>Adversarial Sample Generation Module</a:t>
-            </a:r>
-          </a:p>
-          <a:p>
-            <a:r>
-              <a:rPr lang="en-IN" sz="2000" dirty="0">
-                <a:latin typeface="Times New Roman" panose="02020603050405020304" pitchFamily="18" charset="0"/>
-                <a:cs typeface="Times New Roman" panose="02020603050405020304" pitchFamily="18" charset="0"/>
-              </a:rPr>
-              <a:t>IDS Evaluation &amp; Retraining Module</a:t>
-            </a:r>
-          </a:p>
-          <a:p>
-            <a:endParaRPr lang="en-IN" sz="2000" dirty="0">
-              <a:latin typeface="Times New Roman" panose="02020603050405020304" pitchFamily="18" charset="0"/>
-              <a:cs typeface="Times New Roman" panose="02020603050405020304" pitchFamily="18" charset="0"/>
-            </a:endParaRPr>
-          </a:p>
-          <a:p>
-            <a:r>
-              <a:rPr lang="en-IN" sz="2000" b="1" dirty="0">
-                <a:latin typeface="Times New Roman" panose="02020603050405020304" pitchFamily="18" charset="0"/>
-                <a:cs typeface="Times New Roman" panose="02020603050405020304" pitchFamily="18" charset="0"/>
-              </a:rPr>
-              <a:t>Features:</a:t>
-            </a:r>
-            <a:endParaRPr lang="en-IN" sz="2000" dirty="0">
-              <a:latin typeface="Times New Roman" panose="02020603050405020304" pitchFamily="18" charset="0"/>
-              <a:cs typeface="Times New Roman" panose="02020603050405020304" pitchFamily="18" charset="0"/>
-            </a:endParaRPr>
-          </a:p>
-          <a:p>
-            <a:r>
-              <a:rPr lang="en-IN" sz="2000" dirty="0">
-                <a:latin typeface="Times New Roman" panose="02020603050405020304" pitchFamily="18" charset="0"/>
-                <a:cs typeface="Times New Roman" panose="02020603050405020304" pitchFamily="18" charset="0"/>
-              </a:rPr>
-              <a:t>Top 20 features via MI and SHAP</a:t>
-            </a:r>
-          </a:p>
-          <a:p>
-            <a:r>
-              <a:rPr lang="en-IN" sz="2000" dirty="0">
-                <a:latin typeface="Times New Roman" panose="02020603050405020304" pitchFamily="18" charset="0"/>
-                <a:cs typeface="Times New Roman" panose="02020603050405020304" pitchFamily="18" charset="0"/>
-              </a:rPr>
-              <a:t>Protocol-level fields frozen — IP, flags, port unchanged</a:t>
-            </a:r>
-          </a:p>
-          <a:p>
-            <a:endParaRPr lang="en-IN" sz="2000" b="1" dirty="0">
-              <a:latin typeface="Times New Roman" panose="02020603050405020304" pitchFamily="18" charset="0"/>
-              <a:cs typeface="Times New Roman" panose="02020603050405020304" pitchFamily="18" charset="0"/>
-            </a:endParaRPr>
-          </a:p>
-          <a:p>
-            <a:r>
-              <a:rPr lang="en-IN" sz="2000" b="1" dirty="0">
-                <a:latin typeface="Times New Roman" panose="02020603050405020304" pitchFamily="18" charset="0"/>
-                <a:cs typeface="Times New Roman" panose="02020603050405020304" pitchFamily="18" charset="0"/>
-              </a:rPr>
-              <a:t>Process / Algorithm:</a:t>
-            </a:r>
-            <a:endParaRPr lang="en-IN" sz="2000" dirty="0">
-              <a:latin typeface="Times New Roman" panose="02020603050405020304" pitchFamily="18" charset="0"/>
-              <a:cs typeface="Times New Roman" panose="02020603050405020304" pitchFamily="18" charset="0"/>
-            </a:endParaRPr>
-          </a:p>
-          <a:p>
-            <a:r>
-              <a:rPr lang="en-IN" sz="2000" dirty="0">
-                <a:latin typeface="Times New Roman" panose="02020603050405020304" pitchFamily="18" charset="0"/>
-                <a:cs typeface="Times New Roman" panose="02020603050405020304" pitchFamily="18" charset="0"/>
-              </a:rPr>
-              <a:t>Clean data → encode labels → apply SMOTE</a:t>
-            </a:r>
-          </a:p>
-          <a:p>
-            <a:r>
-              <a:rPr lang="en-IN" sz="2000" dirty="0">
-                <a:latin typeface="Times New Roman" panose="02020603050405020304" pitchFamily="18" charset="0"/>
-                <a:cs typeface="Times New Roman" panose="02020603050405020304" pitchFamily="18" charset="0"/>
-              </a:rPr>
-              <a:t>Variance thresholding → SHAP ranking → freeze constraints</a:t>
-            </a:r>
-          </a:p>
-          <a:p>
-            <a:r>
-              <a:rPr lang="en-IN" sz="2000" dirty="0">
-                <a:latin typeface="Times New Roman" panose="02020603050405020304" pitchFamily="18" charset="0"/>
-                <a:cs typeface="Times New Roman" panose="02020603050405020304" pitchFamily="18" charset="0"/>
-              </a:rPr>
-              <a:t>Train conditional DDPM → generate adversarial samples</a:t>
-            </a:r>
-          </a:p>
-          <a:p>
-            <a:r>
-              <a:rPr lang="en-IN" sz="2000" dirty="0">
-                <a:latin typeface="Times New Roman" panose="02020603050405020304" pitchFamily="18" charset="0"/>
-                <a:cs typeface="Times New Roman" panose="02020603050405020304" pitchFamily="18" charset="0"/>
-              </a:rPr>
-              <a:t>Inject into 7 IDS classifiers → measure evasion rate</a:t>
-            </a:r>
-          </a:p>
-          <a:p>
-            <a:r>
-              <a:rPr lang="en-IN" sz="2000" dirty="0">
-                <a:latin typeface="Times New Roman" panose="02020603050405020304" pitchFamily="18" charset="0"/>
-                <a:cs typeface="Times New Roman" panose="02020603050405020304" pitchFamily="18" charset="0"/>
-              </a:rPr>
-              <a:t>Retrain IDS → measure robustness improvement</a:t>
-            </a:r>
-          </a:p>
-        </p:txBody>
-      </p:sp>
-    </p:spTree>
-    <p:extLst>
-      <p:ext uri="{BB962C8B-B14F-4D97-AF65-F5344CB8AC3E}">
-        <p14:creationId xmlns:p14="http://schemas.microsoft.com/office/powerpoint/2010/main" val="2779650028"/>
-      </p:ext>
-    </p:extLst>
-  </p:cSld>
-  <p:clrMapOvr>
-    <a:masterClrMapping/>
-  </p:clrMapOvr>
-</p:sld>
-</file>
-
-<file path=ppt/slides/slide9.xml><?xml version="1.0" encoding="utf-8"?>
 <p:sld xmlns:a="http://schemas.openxmlformats.org/drawingml/2006/main" xmlns:r="http://schemas.openxmlformats.org/officeDocument/2006/relationships" xmlns:p="http://schemas.openxmlformats.org/presentationml/2006/main">
   <p:cSld>
     <p:spTree>
@@ -13031,7 +13153,7 @@
                 </a:solidFill>
                 <a:latin typeface="Times New Roman"/>
               </a:rPr>
-              <a:t>7.Dataset</a:t>
+              <a:t>6.Dataset</a:t>
             </a:r>
             <a:endParaRPr lang="en-IN" sz="3600" b="1" u="none" strike="noStrike" dirty="0">
               <a:solidFill>
@@ -13161,7 +13283,7 @@
                 <a:uFillTx/>
                 <a:latin typeface="Calibri"/>
               </a:rPr>
-              <a:t>9</a:t>
+              <a:t>8</a:t>
             </a:fld>
             <a:endParaRPr lang="en-IN" sz="1200" b="0" u="none" strike="noStrike">
               <a:solidFill>
@@ -13515,6 +13637,570 @@
     <p:extLst>
       <p:ext uri="{BB962C8B-B14F-4D97-AF65-F5344CB8AC3E}">
         <p14:creationId xmlns:p14="http://schemas.microsoft.com/office/powerpoint/2010/main" val="3184357187"/>
+      </p:ext>
+    </p:extLst>
+  </p:cSld>
+  <p:clrMapOvr>
+    <a:masterClrMapping/>
+  </p:clrMapOvr>
+</p:sld>
+</file>
+
+<file path=ppt/slides/slide9.xml><?xml version="1.0" encoding="utf-8"?>
+<p:sld xmlns:a="http://schemas.openxmlformats.org/drawingml/2006/main" xmlns:r="http://schemas.openxmlformats.org/officeDocument/2006/relationships" xmlns:p="http://schemas.openxmlformats.org/presentationml/2006/main">
+  <p:cSld>
+    <p:spTree>
+      <p:nvGrpSpPr>
+        <p:cNvPr id="1" name="">
+          <a:extLst>
+            <a:ext uri="{FF2B5EF4-FFF2-40B4-BE49-F238E27FC236}">
+              <a16:creationId xmlns:a16="http://schemas.microsoft.com/office/drawing/2014/main" id="{63BAA2D7-0EC1-2043-0B7D-493E08079E77}"/>
+            </a:ext>
+          </a:extLst>
+        </p:cNvPr>
+        <p:cNvGrpSpPr/>
+        <p:nvPr/>
+      </p:nvGrpSpPr>
+      <p:grpSpPr>
+        <a:xfrm>
+          <a:off x="0" y="0"/>
+          <a:ext cx="0" cy="0"/>
+          <a:chOff x="0" y="0"/>
+          <a:chExt cx="0" cy="0"/>
+        </a:xfrm>
+      </p:grpSpPr>
+      <p:sp>
+        <p:nvSpPr>
+          <p:cNvPr id="88" name="PlaceHolder 1">
+            <a:extLst>
+              <a:ext uri="{FF2B5EF4-FFF2-40B4-BE49-F238E27FC236}">
+                <a16:creationId xmlns:a16="http://schemas.microsoft.com/office/drawing/2014/main" id="{D6F6279F-F26F-B59B-0891-0523503EF4BF}"/>
+              </a:ext>
+            </a:extLst>
+          </p:cNvPr>
+          <p:cNvSpPr>
+            <a:spLocks noGrp="1"/>
+          </p:cNvSpPr>
+          <p:nvPr>
+            <p:ph type="title"/>
+          </p:nvPr>
+        </p:nvSpPr>
+        <p:spPr>
+          <a:prstGeom prst="rect">
+            <a:avLst/>
+          </a:prstGeom>
+          <a:noFill/>
+          <a:ln w="0">
+            <a:noFill/>
+          </a:ln>
+        </p:spPr>
+        <p:txBody>
+          <a:bodyPr lIns="91440" tIns="45720" rIns="91440" bIns="45720" anchor="ctr">
+            <a:normAutofit/>
+          </a:bodyPr>
+          <a:lstStyle/>
+          <a:p>
+            <a:pPr algn="ctr">
+              <a:lnSpc>
+                <a:spcPct val="100000"/>
+              </a:lnSpc>
+              <a:tabLst>
+                <a:tab pos="0" algn="l"/>
+              </a:tabLst>
+            </a:pPr>
+            <a:r>
+              <a:rPr lang="en-US" sz="3600" b="1" dirty="0">
+                <a:solidFill>
+                  <a:srgbClr val="780373"/>
+                </a:solidFill>
+                <a:latin typeface="Times New Roman"/>
+              </a:rPr>
+              <a:t>7.References</a:t>
+            </a:r>
+            <a:endParaRPr lang="en-IN" sz="3600" b="1" u="none" strike="noStrike" dirty="0">
+              <a:solidFill>
+                <a:srgbClr val="000000"/>
+              </a:solidFill>
+              <a:effectLst/>
+              <a:uFillTx/>
+              <a:latin typeface="Arial"/>
+            </a:endParaRPr>
+          </a:p>
+        </p:txBody>
+      </p:sp>
+      <p:sp>
+        <p:nvSpPr>
+          <p:cNvPr id="2" name="Slide Number Placeholder 1">
+            <a:extLst>
+              <a:ext uri="{FF2B5EF4-FFF2-40B4-BE49-F238E27FC236}">
+                <a16:creationId xmlns:a16="http://schemas.microsoft.com/office/drawing/2014/main" id="{77B0D8AC-B975-77B0-76F7-69CA5420A6A4}"/>
+              </a:ext>
+            </a:extLst>
+          </p:cNvPr>
+          <p:cNvSpPr>
+            <a:spLocks noGrp="1"/>
+          </p:cNvSpPr>
+          <p:nvPr>
+            <p:ph type="sldNum" idx="18"/>
+          </p:nvPr>
+        </p:nvSpPr>
+        <p:spPr/>
+        <p:txBody>
+          <a:bodyPr/>
+          <a:lstStyle/>
+          <a:p>
+            <a:pPr indent="0" algn="r" defTabSz="914400">
+              <a:lnSpc>
+                <a:spcPct val="100000"/>
+              </a:lnSpc>
+              <a:buNone/>
+              <a:tabLst>
+                <a:tab pos="0" algn="l"/>
+              </a:tabLst>
+            </a:pPr>
+            <a:fld id="{9118F6E7-F1DC-4F9F-A55D-F4F9EDAF9867}" type="slidenum">
+              <a:rPr lang="en-US" sz="1200" b="0" u="none" strike="noStrike" smtClean="0">
+                <a:solidFill>
+                  <a:schemeClr val="dk1">
+                    <a:tint val="75000"/>
+                  </a:schemeClr>
+                </a:solidFill>
+                <a:effectLst/>
+                <a:uFillTx/>
+                <a:latin typeface="Calibri"/>
+              </a:rPr>
+              <a:t>9</a:t>
+            </a:fld>
+            <a:endParaRPr lang="en-IN" sz="1200" b="0" u="none" strike="noStrike">
+              <a:solidFill>
+                <a:srgbClr val="000000"/>
+              </a:solidFill>
+              <a:effectLst/>
+              <a:uFillTx/>
+              <a:latin typeface="Times New Roman"/>
+            </a:endParaRPr>
+          </a:p>
+        </p:txBody>
+      </p:sp>
+      <p:sp>
+        <p:nvSpPr>
+          <p:cNvPr id="90" name="PlaceHolder 1">
+            <a:extLst>
+              <a:ext uri="{FF2B5EF4-FFF2-40B4-BE49-F238E27FC236}">
+                <a16:creationId xmlns:a16="http://schemas.microsoft.com/office/drawing/2014/main" id="{8A0B1B03-2A22-9A6D-2FEB-B3467A5200FE}"/>
+              </a:ext>
+            </a:extLst>
+          </p:cNvPr>
+          <p:cNvSpPr/>
+          <p:nvPr/>
+        </p:nvSpPr>
+        <p:spPr>
+          <a:xfrm>
+            <a:off x="115200" y="118440"/>
+            <a:ext cx="11960640" cy="338760"/>
+          </a:xfrm>
+          <a:prstGeom prst="rect">
+            <a:avLst/>
+          </a:prstGeom>
+          <a:noFill/>
+          <a:ln w="0">
+            <a:noFill/>
+          </a:ln>
+        </p:spPr>
+        <p:style>
+          <a:lnRef idx="0">
+            <a:scrgbClr r="0" g="0" b="0"/>
+          </a:lnRef>
+          <a:fillRef idx="0">
+            <a:scrgbClr r="0" g="0" b="0"/>
+          </a:fillRef>
+          <a:effectRef idx="0">
+            <a:scrgbClr r="0" g="0" b="0"/>
+          </a:effectRef>
+          <a:fontRef idx="minor"/>
+        </p:style>
+        <p:txBody>
+          <a:bodyPr lIns="90000" tIns="45000" rIns="90000" bIns="45000" anchor="ctr">
+            <a:normAutofit/>
+          </a:bodyPr>
+          <a:lstStyle/>
+          <a:p>
+            <a:pPr algn="ctr">
+              <a:tabLst>
+                <a:tab pos="0" algn="l"/>
+              </a:tabLst>
+            </a:pPr>
+            <a:r>
+              <a:rPr lang="en-US" sz="1600" b="0" u="none" strike="noStrike" dirty="0">
+                <a:solidFill>
+                  <a:schemeClr val="dk1"/>
+                </a:solidFill>
+                <a:effectLst/>
+                <a:uFillTx/>
+                <a:latin typeface="Times New Roman"/>
+              </a:rPr>
+              <a:t>Batch No. C6       										 	</a:t>
+            </a:r>
+            <a:r>
+              <a:rPr lang="en-US" sz="1600" b="1" dirty="0">
+                <a:latin typeface="Times New Roman"/>
+              </a:rPr>
+              <a:t>DCTM</a:t>
+            </a:r>
+            <a:endParaRPr lang="en-IN" sz="1600" b="0" u="none" strike="noStrike" dirty="0">
+              <a:solidFill>
+                <a:srgbClr val="000000"/>
+              </a:solidFill>
+              <a:effectLst/>
+              <a:uFillTx/>
+              <a:latin typeface="Arial"/>
+            </a:endParaRPr>
+          </a:p>
+        </p:txBody>
+      </p:sp>
+      <p:sp>
+        <p:nvSpPr>
+          <p:cNvPr id="5" name="Rectangle 3">
+            <a:extLst>
+              <a:ext uri="{FF2B5EF4-FFF2-40B4-BE49-F238E27FC236}">
+                <a16:creationId xmlns:a16="http://schemas.microsoft.com/office/drawing/2014/main" id="{CD28AE65-4C0F-A377-202A-5E5D182BD470}"/>
+              </a:ext>
+            </a:extLst>
+          </p:cNvPr>
+          <p:cNvSpPr>
+            <a:spLocks noChangeArrowheads="1"/>
+          </p:cNvSpPr>
+          <p:nvPr/>
+        </p:nvSpPr>
+        <p:spPr bwMode="auto">
+          <a:xfrm>
+            <a:off x="0" y="-184666"/>
+            <a:ext cx="184731" cy="369332"/>
+          </a:xfrm>
+          <a:prstGeom prst="rect">
+            <a:avLst/>
+          </a:prstGeom>
+          <a:noFill/>
+          <a:ln>
+            <a:noFill/>
+          </a:ln>
+          <a:effectLst/>
+          <a:extLst>
+            <a:ext uri="{909E8E84-426E-40DD-AFC4-6F175D3DCCD1}">
+              <a14:hiddenFill xmlns:a14="http://schemas.microsoft.com/office/drawing/2010/main">
+                <a:solidFill>
+                  <a:schemeClr val="accent1"/>
+                </a:solidFill>
+              </a14:hiddenFill>
+            </a:ext>
+            <a:ext uri="{91240B29-F687-4F45-9708-019B960494DF}">
+              <a14:hiddenLine xmlns:a14="http://schemas.microsoft.com/office/drawing/2010/main" w="9525">
+                <a:solidFill>
+                  <a:schemeClr val="tx1"/>
+                </a:solidFill>
+                <a:miter lim="800000"/>
+                <a:headEnd/>
+                <a:tailEnd/>
+              </a14:hiddenLine>
+            </a:ext>
+            <a:ext uri="{AF507438-7753-43E0-B8FC-AC1667EBCBE1}">
+              <a14:hiddenEffects xmlns:a14="http://schemas.microsoft.com/office/drawing/2010/main">
+                <a:effectLst>
+                  <a:outerShdw dist="35921" dir="2700000" algn="ctr" rotWithShape="0">
+                    <a:schemeClr val="bg2"/>
+                  </a:outerShdw>
+                </a:effectLst>
+              </a14:hiddenEffects>
+            </a:ext>
+          </a:extLst>
+        </p:spPr>
+        <p:txBody>
+          <a:bodyPr vert="horz" wrap="none" lIns="91440" tIns="45720" rIns="91440" bIns="45720" numCol="1" anchor="ctr" anchorCtr="0" compatLnSpc="1">
+            <a:prstTxWarp prst="textNoShape">
+              <a:avLst/>
+            </a:prstTxWarp>
+            <a:spAutoFit/>
+          </a:bodyPr>
+          <a:lstStyle/>
+          <a:p>
+            <a:pPr marL="0" marR="0" lvl="0" indent="0" algn="l" defTabSz="914400" rtl="0" eaLnBrk="0" fontAlgn="base" latinLnBrk="0" hangingPunct="0">
+              <a:lnSpc>
+                <a:spcPct val="100000"/>
+              </a:lnSpc>
+              <a:spcBef>
+                <a:spcPct val="0"/>
+              </a:spcBef>
+              <a:spcAft>
+                <a:spcPct val="0"/>
+              </a:spcAft>
+              <a:buClrTx/>
+              <a:buSzTx/>
+              <a:buFontTx/>
+              <a:buNone/>
+              <a:tabLst/>
+            </a:pPr>
+            <a:endParaRPr kumimoji="0" lang="en-US" altLang="en-US" sz="1800" b="0" i="0" u="none" strike="noStrike" cap="none" normalizeH="0" baseline="0" dirty="0">
+              <a:ln>
+                <a:noFill/>
+              </a:ln>
+              <a:solidFill>
+                <a:schemeClr val="tx1"/>
+              </a:solidFill>
+              <a:effectLst/>
+              <a:latin typeface="Arial" panose="020B0604020202020204" pitchFamily="34" charset="0"/>
+            </a:endParaRPr>
+          </a:p>
+        </p:txBody>
+      </p:sp>
+      <p:sp>
+        <p:nvSpPr>
+          <p:cNvPr id="15" name="Rectangle 6">
+            <a:extLst>
+              <a:ext uri="{FF2B5EF4-FFF2-40B4-BE49-F238E27FC236}">
+                <a16:creationId xmlns:a16="http://schemas.microsoft.com/office/drawing/2014/main" id="{8F2BD0C5-43C4-1845-1E4B-D80582CB1186}"/>
+              </a:ext>
+            </a:extLst>
+          </p:cNvPr>
+          <p:cNvSpPr>
+            <a:spLocks noGrp="1" noChangeArrowheads="1"/>
+          </p:cNvSpPr>
+          <p:nvPr>
+            <p:ph type="body"/>
+          </p:nvPr>
+        </p:nvSpPr>
+        <p:spPr bwMode="auto">
+          <a:xfrm>
+            <a:off x="431136" y="1887580"/>
+            <a:ext cx="11149704" cy="2677656"/>
+          </a:xfrm>
+          <a:prstGeom prst="rect">
+            <a:avLst/>
+          </a:prstGeom>
+          <a:noFill/>
+          <a:ln>
+            <a:noFill/>
+          </a:ln>
+          <a:effectLst/>
+          <a:extLst>
+            <a:ext uri="{909E8E84-426E-40DD-AFC4-6F175D3DCCD1}">
+              <a14:hiddenFill xmlns:a14="http://schemas.microsoft.com/office/drawing/2010/main">
+                <a:solidFill>
+                  <a:schemeClr val="accent1"/>
+                </a:solidFill>
+              </a14:hiddenFill>
+            </a:ext>
+            <a:ext uri="{91240B29-F687-4F45-9708-019B960494DF}">
+              <a14:hiddenLine xmlns:a14="http://schemas.microsoft.com/office/drawing/2010/main" w="9525">
+                <a:solidFill>
+                  <a:schemeClr val="tx1"/>
+                </a:solidFill>
+                <a:miter lim="800000"/>
+                <a:headEnd/>
+                <a:tailEnd/>
+              </a14:hiddenLine>
+            </a:ext>
+            <a:ext uri="{AF507438-7753-43E0-B8FC-AC1667EBCBE1}">
+              <a14:hiddenEffects xmlns:a14="http://schemas.microsoft.com/office/drawing/2010/main">
+                <a:effectLst>
+                  <a:outerShdw dist="35921" dir="2700000" algn="ctr" rotWithShape="0">
+                    <a:schemeClr val="bg2"/>
+                  </a:outerShdw>
+                </a:effectLst>
+              </a14:hiddenEffects>
+            </a:ext>
+          </a:extLst>
+        </p:spPr>
+        <p:txBody>
+          <a:bodyPr vert="horz" wrap="square" lIns="91440" tIns="45720" rIns="91440" bIns="45720" numCol="1" anchor="ctr" anchorCtr="0" compatLnSpc="1">
+            <a:prstTxWarp prst="textNoShape">
+              <a:avLst/>
+            </a:prstTxWarp>
+            <a:spAutoFit/>
+          </a:bodyPr>
+          <a:lstStyle/>
+          <a:p>
+            <a:pPr marL="457200" marR="0" lvl="0" indent="-457200" algn="just" defTabSz="914400" rtl="0" eaLnBrk="0" fontAlgn="base" latinLnBrk="0" hangingPunct="0">
+              <a:lnSpc>
+                <a:spcPct val="100000"/>
+              </a:lnSpc>
+              <a:spcBef>
+                <a:spcPct val="0"/>
+              </a:spcBef>
+              <a:spcAft>
+                <a:spcPct val="0"/>
+              </a:spcAft>
+              <a:buClrTx/>
+              <a:buSzTx/>
+              <a:buFont typeface="+mj-lt"/>
+              <a:buAutoNum type="arabicPeriod"/>
+              <a:tabLst/>
+            </a:pPr>
+            <a:endParaRPr kumimoji="0" lang="en-US" altLang="en-US" sz="2400" b="0" i="0" u="none" strike="noStrike" cap="none" normalizeH="0" baseline="0" dirty="0">
+              <a:ln>
+                <a:noFill/>
+              </a:ln>
+              <a:solidFill>
+                <a:schemeClr val="tx1"/>
+              </a:solidFill>
+              <a:effectLst/>
+              <a:latin typeface="Times New Roman" panose="02020603050405020304" pitchFamily="18" charset="0"/>
+              <a:cs typeface="Times New Roman" panose="02020603050405020304" pitchFamily="18" charset="0"/>
+            </a:endParaRPr>
+          </a:p>
+          <a:p>
+            <a:pPr marL="457200" indent="-457200" algn="just" eaLnBrk="0" fontAlgn="base" hangingPunct="0">
+              <a:lnSpc>
+                <a:spcPct val="100000"/>
+              </a:lnSpc>
+              <a:spcBef>
+                <a:spcPct val="0"/>
+              </a:spcBef>
+              <a:spcAft>
+                <a:spcPct val="0"/>
+              </a:spcAft>
+              <a:buFont typeface="+mj-lt"/>
+              <a:buAutoNum type="arabicPeriod"/>
+            </a:pPr>
+            <a:r>
+              <a:rPr kumimoji="0" lang="en-US" altLang="en-US" sz="2400" b="0" i="0" u="none" strike="noStrike" cap="none" normalizeH="0" baseline="0" dirty="0">
+                <a:ln>
+                  <a:noFill/>
+                </a:ln>
+                <a:solidFill>
+                  <a:schemeClr val="tx1"/>
+                </a:solidFill>
+                <a:effectLst/>
+                <a:latin typeface="Times New Roman" panose="02020603050405020304" pitchFamily="18" charset="0"/>
+                <a:cs typeface="Times New Roman" panose="02020603050405020304" pitchFamily="18" charset="0"/>
+              </a:rPr>
+              <a:t>DEMGAN: A Machine Learning-Based Intrusion Detection System Evasion Scheme.2025. </a:t>
+            </a:r>
+            <a:r>
+              <a:rPr kumimoji="0" lang="en-US" altLang="en-US" sz="2400" b="0" i="1" u="none" strike="noStrike" cap="none" normalizeH="0" baseline="0" dirty="0">
+                <a:ln>
+                  <a:noFill/>
+                </a:ln>
+                <a:solidFill>
+                  <a:schemeClr val="tx1"/>
+                </a:solidFill>
+                <a:effectLst/>
+                <a:latin typeface="Times New Roman" panose="02020603050405020304" pitchFamily="18" charset="0"/>
+                <a:cs typeface="Times New Roman" panose="02020603050405020304" pitchFamily="18" charset="0"/>
+              </a:rPr>
+              <a:t>(Base Paper)</a:t>
+            </a:r>
+            <a:r>
+              <a:rPr kumimoji="0" lang="en-US" altLang="en-US" sz="2400" b="0" i="0" u="none" strike="noStrike" cap="none" normalizeH="0" baseline="0" dirty="0">
+                <a:ln>
+                  <a:noFill/>
+                </a:ln>
+                <a:solidFill>
+                  <a:schemeClr val="tx1"/>
+                </a:solidFill>
+                <a:effectLst/>
+                <a:latin typeface="Times New Roman" panose="02020603050405020304" pitchFamily="18" charset="0"/>
+                <a:cs typeface="Times New Roman" panose="02020603050405020304" pitchFamily="18" charset="0"/>
+              </a:rPr>
+              <a:t> </a:t>
+            </a:r>
+          </a:p>
+          <a:p>
+            <a:pPr marL="457200" indent="-457200" algn="just" eaLnBrk="0" fontAlgn="base" hangingPunct="0">
+              <a:lnSpc>
+                <a:spcPct val="100000"/>
+              </a:lnSpc>
+              <a:spcBef>
+                <a:spcPct val="0"/>
+              </a:spcBef>
+              <a:spcAft>
+                <a:spcPct val="0"/>
+              </a:spcAft>
+              <a:buFont typeface="+mj-lt"/>
+              <a:buAutoNum type="arabicPeriod"/>
+            </a:pPr>
+            <a:r>
+              <a:rPr kumimoji="0" lang="en-US" altLang="en-US" sz="2400" b="0" i="0" u="none" strike="noStrike" cap="none" normalizeH="0" baseline="0" dirty="0">
+                <a:ln>
+                  <a:noFill/>
+                </a:ln>
+                <a:solidFill>
+                  <a:schemeClr val="tx1"/>
+                </a:solidFill>
+                <a:effectLst/>
+                <a:latin typeface="Times New Roman" panose="02020603050405020304" pitchFamily="18" charset="0"/>
+                <a:cs typeface="Times New Roman" panose="02020603050405020304" pitchFamily="18" charset="0"/>
+              </a:rPr>
+              <a:t>Wasserstein GAN. 2017. </a:t>
+            </a:r>
+          </a:p>
+          <a:p>
+            <a:pPr marL="457200" indent="-457200" algn="just" eaLnBrk="0" fontAlgn="base" hangingPunct="0">
+              <a:lnSpc>
+                <a:spcPct val="100000"/>
+              </a:lnSpc>
+              <a:spcBef>
+                <a:spcPct val="0"/>
+              </a:spcBef>
+              <a:spcAft>
+                <a:spcPct val="0"/>
+              </a:spcAft>
+              <a:buFont typeface="+mj-lt"/>
+              <a:buAutoNum type="arabicPeriod"/>
+            </a:pPr>
+            <a:r>
+              <a:rPr kumimoji="0" lang="en-US" altLang="en-US" sz="2400" b="0" i="0" u="none" strike="noStrike" cap="none" normalizeH="0" baseline="0" dirty="0">
+                <a:ln>
+                  <a:noFill/>
+                </a:ln>
+                <a:solidFill>
+                  <a:schemeClr val="tx1"/>
+                </a:solidFill>
+                <a:effectLst/>
+                <a:latin typeface="Times New Roman" panose="02020603050405020304" pitchFamily="18" charset="0"/>
+                <a:cs typeface="Times New Roman" panose="02020603050405020304" pitchFamily="18" charset="0"/>
+              </a:rPr>
+              <a:t>Identifying Relevant Features of CSE-CIC-IDS2018 Dataset for the Development of an Intrusion Detection System. 2023 .</a:t>
+            </a:r>
+          </a:p>
+          <a:p>
+            <a:pPr marL="457200" indent="-457200" algn="just" eaLnBrk="0" fontAlgn="base" hangingPunct="0">
+              <a:lnSpc>
+                <a:spcPct val="100000"/>
+              </a:lnSpc>
+              <a:spcBef>
+                <a:spcPct val="0"/>
+              </a:spcBef>
+              <a:spcAft>
+                <a:spcPct val="0"/>
+              </a:spcAft>
+              <a:buFont typeface="+mj-lt"/>
+              <a:buAutoNum type="arabicPeriod"/>
+            </a:pPr>
+            <a:r>
+              <a:rPr lang="en-IN" sz="2400" dirty="0">
+                <a:latin typeface="Times New Roman" panose="02020603050405020304" pitchFamily="18" charset="0"/>
+                <a:cs typeface="Times New Roman" panose="02020603050405020304" pitchFamily="18" charset="0"/>
+              </a:rPr>
+              <a:t>SMOTE: Synthetic Minority Over-sampling Technique. 2002.</a:t>
+            </a:r>
+            <a:endParaRPr kumimoji="0" lang="en-US" altLang="en-US" sz="2400" b="0" i="0" u="none" strike="noStrike" cap="none" normalizeH="0" baseline="0" dirty="0">
+              <a:ln>
+                <a:noFill/>
+              </a:ln>
+              <a:solidFill>
+                <a:schemeClr val="tx1"/>
+              </a:solidFill>
+              <a:effectLst/>
+              <a:latin typeface="Times New Roman" panose="02020603050405020304" pitchFamily="18" charset="0"/>
+              <a:cs typeface="Times New Roman" panose="02020603050405020304" pitchFamily="18" charset="0"/>
+            </a:endParaRPr>
+          </a:p>
+        </p:txBody>
+      </p:sp>
+    </p:spTree>
+    <p:extLst>
+      <p:ext uri="{BB962C8B-B14F-4D97-AF65-F5344CB8AC3E}">
+        <p14:creationId xmlns:p14="http://schemas.microsoft.com/office/powerpoint/2010/main" val="286242953"/>
       </p:ext>
     </p:extLst>
   </p:cSld>

</xml_diff>